<commit_message>
datos: cifras verificadas con microdatos de defunciones y egresos 2024
</commit_message>
<xml_diff>
--- a/submission/Los_Antimarrulla_Pitch_Tamizaje.pptx
+++ b/submission/Los_Antimarrulla_Pitch_Tamizaje.pptx
@@ -114,30 +114,30 @@
   <p:extLst>
     <p:ext uri="{521415D9-36F7-43E2-AB2F-B90AF26B5E84}">
       <p14:sectionLst xmlns:p14="http://schemas.microsoft.com/office/powerpoint/2010/main">
-        <p14:section name="Portada" id="{6a221a61-f911-6a98-9da2-1f41fb1f172b}">
+        <p14:section name="Portada" id="{cbc74d54-624e-9729-fbaf-84981a549a0c}">
           <p14:sldIdLst>
             <p14:sldId id="256"/>
           </p14:sldIdLst>
         </p14:section>
-        <p14:section name="Problema y solución" id="{dbeb2c4e-4607-df0e-90cd-eab979ca44a2}">
+        <p14:section name="Problema y solución" id="{7059359c-ec83-802a-2e7f-acc4d1f398b9}">
           <p14:sldIdLst>
             <p14:sldId id="257"/>
             <p14:sldId id="258"/>
           </p14:sldIdLst>
         </p14:section>
-        <p14:section name="Tecnología" id="{d0525ad0-c4c3-77a7-1189-b0bf66e03ee4}">
+        <p14:section name="Tecnología" id="{332d058f-68d9-ddb1-525f-8dd44d759e51}">
           <p14:sldIdLst>
             <p14:sldId id="259"/>
             <p14:sldId id="260"/>
           </p14:sldIdLst>
         </p14:section>
-        <p14:section name="Demo y datos" id="{f44c845b-8f76-1a66-42a0-9f5aaed51b29}">
+        <p14:section name="Demo y datos" id="{ed46450c-df22-3305-7536-66be41c56866}">
           <p14:sldIdLst>
             <p14:sldId id="261"/>
             <p14:sldId id="262"/>
           </p14:sldIdLst>
         </p14:section>
-        <p14:section name="Impacto y cierre" id="{472abfed-28f7-0a78-c15a-0f88967635f0}">
+        <p14:section name="Impacto y cierre" id="{06c5abc0-b7d9-7293-09dd-c5ec65804859}">
           <p14:sldIdLst>
             <p14:sldId id="263"/>
           </p14:sldIdLst>
@@ -634,7 +634,7 @@
           <a:p>
             <a:r>
               <a:rPr lang="en-US" dirty="0"/>
-              <a:t>En México, 18.3% de los adultos vive con diabetes y uno de cada tres no lo sabe. En 2024 murieron 112 mil personas por diabetes: la segunda causa de muerte. Los hospitales tienen los datos para detectarla antes, pero no pueden compartirlos: hacerlo es un riesgo legal y de privacidad; no hacerlo significa detectar tarde. ¿Y si la IA pudiera calcular el riesgo sin ver jamás los datos?</a:t>
+              <a:t>En México, 18.3% de los adultos vive con diabetes y uno de cada tres no lo sabe. En 2024 murieron 112 mil personas por diabetes: la segunda causa de muerte. Y solo en hospitales de la Secretaría de Salud hubo más de 11 mil amputaciones por diabetes (11,550; 18.4% de sus hospitalizaciones por diabetes). Los hospitales tienen los datos para detectarla antes, pero no pueden compartirlos: hacerlo es un riesgo legal y de privacidad; no hacerlo significa detectar tarde. ¿Y si la IA pudiera calcular el riesgo sin ver jamás los datos?</a:t>
             </a:r>
             <a:endParaRPr lang="en-US" dirty="0"/>
           </a:p>
@@ -2649,7 +2649,7 @@
                   <a:schemeClr val="accent5"/>
                 </a:solidFill>
               </a:rPr>
-              <a:t>112,641</a:t>
+              <a:t>112,577</a:t>
             </a:r>
             <a:endParaRPr lang="en-US" sz="4400" dirty="0"/>
           </a:p>
@@ -3232,7 +3232,7 @@
                   <a:schemeClr val="accent6"/>
                 </a:solidFill>
               </a:rPr>
-              <a:t>Fuentes: ENSANUT 2022 (Basto-Abreu et al., Salud Pública de México, 2023); INEGI, Estadísticas de Defunciones Registradas 2024 (preliminar).</a:t>
+              <a:t>Fuentes: ENSANUT 2022 (Basto-Abreu et al., Salud Pública de México, 2023); defunciones registradas 2024 y egresos hospitalarios SSA 2024, microdatos DGIS/INEGI.</a:t>
             </a:r>
             <a:endParaRPr lang="en-US" sz="1000" dirty="0"/>
           </a:p>

</xml_diff>

<commit_message>
audit: correcciones sin decisión (cifras, protocolo Paillier, métricas, licencias, scripts reproducibles, deck y sitio)
</commit_message>
<xml_diff>
--- a/submission/Los_Antimarrulla_Pitch_Tamizaje.pptx
+++ b/submission/Los_Antimarrulla_Pitch_Tamizaje.pptx
@@ -114,30 +114,30 @@
   <p:extLst>
     <p:ext uri="{521415D9-36F7-43E2-AB2F-B90AF26B5E84}">
       <p14:sectionLst xmlns:p14="http://schemas.microsoft.com/office/powerpoint/2010/main">
-        <p14:section name="Portada" id="{cbc74d54-624e-9729-fbaf-84981a549a0c}">
+        <p14:section name="Portada" id="{9cb336fb-08bc-168b-953a-8a0176050050}">
           <p14:sldIdLst>
             <p14:sldId id="256"/>
           </p14:sldIdLst>
         </p14:section>
-        <p14:section name="Problema y solución" id="{7059359c-ec83-802a-2e7f-acc4d1f398b9}">
+        <p14:section name="Problema y solución" id="{b6938fb9-8e33-66e9-8e5d-fec9ab9adb74}">
           <p14:sldIdLst>
             <p14:sldId id="257"/>
             <p14:sldId id="258"/>
           </p14:sldIdLst>
         </p14:section>
-        <p14:section name="Tecnología" id="{332d058f-68d9-ddb1-525f-8dd44d759e51}">
+        <p14:section name="Tecnología" id="{2bde8551-23af-d9fd-02ae-67e149905b0b}">
           <p14:sldIdLst>
             <p14:sldId id="259"/>
             <p14:sldId id="260"/>
           </p14:sldIdLst>
         </p14:section>
-        <p14:section name="Demo y datos" id="{ed46450c-df22-3305-7536-66be41c56866}">
+        <p14:section name="Demo y datos" id="{071dd8da-afd0-753d-3256-80c53e23b3e9}">
           <p14:sldIdLst>
             <p14:sldId id="261"/>
             <p14:sldId id="262"/>
           </p14:sldIdLst>
         </p14:section>
-        <p14:section name="Impacto y cierre" id="{06c5abc0-b7d9-7293-09dd-c5ec65804859}">
+        <p14:section name="Impacto y cierre" id="{0693b817-cfa8-e0a4-4402-85181226d90c}">
           <p14:sldIdLst>
             <p14:sldId id="263"/>
           </p14:sldIdLst>
@@ -634,7 +634,7 @@
           <a:p>
             <a:r>
               <a:rPr lang="en-US" dirty="0"/>
-              <a:t>En México, 18.3% de los adultos vive con diabetes y uno de cada tres no lo sabe. En 2024 murieron 112 mil personas por diabetes: la segunda causa de muerte. Y solo en hospitales de la Secretaría de Salud hubo más de 11 mil amputaciones por diabetes (11,550; 18.4% de sus hospitalizaciones por diabetes). Los hospitales tienen los datos para detectarla antes, pero no pueden compartirlos: hacerlo es un riesgo legal y de privacidad; no hacerlo significa detectar tarde. ¿Y si la IA pudiera calcular el riesgo sin ver jamás los datos?</a:t>
+              <a:t>En México, 18.3% de los adultos vive con diabetes y uno de cada tres no lo sabe. En 2024 murieron 112 mil personas por diabetes: la segunda causa de muerte. Los hospitales tienen los datos para detectarla antes, pero no pueden compartirlos: hacerlo es un riesgo legal y de privacidad; no hacerlo significa detectar tarde. ¿Y si la IA pudiera calcular el riesgo sin ver jamás los datos?</a:t>
             </a:r>
             <a:endParaRPr lang="en-US" dirty="0"/>
           </a:p>
@@ -810,7 +810,7 @@
           <a:p>
             <a:r>
               <a:rPr lang="en-US" dirty="0"/>
-              <a:t>Este es el corazón del Reto 2. Usamos cifrado homomórfico Paillier: multiplicar cifrados suma los valores y elevar un cifrado a una potencia lo multiplica. Con eso, el servidor calcula el puntaje de una regresión logística sin descifrar nada. Además, TLS 1.3 en tránsito y AES-256-GCM acelerado por CPACF en reposo. Ni el servidor ni nosotros vemos datos de pacientes. ANTES DE PRESENTAR: capturar 'openssl speed -evp aes-256-gcm' en la VM como evidencia.</a:t>
+              <a:t>Este es el corazón del Reto 2. Usamos cifrado homomórfico Paillier: multiplicar cifrados suma los valores y elevar un cifrado a una potencia lo multiplica. Con eso, el servidor calcula el puntaje de una regresión logística sin descifrar nada. Además, TLS 1.3 en tránsito y AES-256-GCM acelerado por CPACF en reposo. El servicio de riesgo nunca ve datos en claro: la llave se queda con el hospital, y quien administre el entorno del hospital es parte de la frontera de confianza. ANTES DE PRESENTAR: capturar 'openssl speed -evp aes-256-gcm' en la VM como evidencia.</a:t>
             </a:r>
             <a:endParaRPr lang="en-US" dirty="0"/>
           </a:p>
@@ -1074,7 +1074,7 @@
           <a:p>
             <a:r>
               <a:rPr lang="en-US" dirty="0"/>
-              <a:t>Entrenamos con datos públicos: 253,680 respuestas de la encuesta de salud de los CDC, con 21 indicadores. Los datos de pacientes reales solo llegan cifrados. El riesgo número uno que señalaron los jueces fue que la biblioteca de cifrado no compilara en s390x; por eso tenemos una ruta garantizada con Paillier en Python puro y una ruta ambiciosa con CKKS que decidimos en la hora 2.</a:t>
+              <a:t>Entrenamos con datos públicos: 253,680 respuestas de la encuesta de salud de los CDC, con 21 indicadores. Los datos de pacientes reales solo llegan cifrados. Medimos AUC, AUC-PR, sensibilidad, especificidad, calibración y el error numérico entre claro y cifrado. Es una prueba técnica con datos de EE. UU.; la validamos con adultos mexicanos de ENSANUT.</a:t>
             </a:r>
             <a:endParaRPr lang="en-US" dirty="0"/>
           </a:p>
@@ -1162,7 +1162,7 @@
           <a:p>
             <a:r>
               <a:rPr lang="en-US" dirty="0"/>
-              <a:t>El impacto: tamizaje temprano para el tercio de personas que no sabe que tiene diabetes, confianza del paciente y cumplimiento con la ley de protección de datos, en un esquema que escala a otras enfermedades crónicas. La IA ve el riesgo; nadie ve al paciente. Somos Los Antimarrulla. Gracias.</a:t>
+              <a:t>El impacto: tamizaje temprano para el tercio de personas que no sabe que tiene diabetes; en 2024, más de 11 mil hospitalizaciones por diabetes en la Secretaría de Salud incluyeron una amputación, confianza del paciente y cumplimiento con la ley de protección de datos, en un esquema que escala a otras enfermedades crónicas. La IA ve el riesgo; nadie ve al paciente. Somos Los Antimarrulla. Gracias.</a:t>
             </a:r>
             <a:endParaRPr lang="en-US" dirty="0"/>
           </a:p>
@@ -6201,7 +6201,7 @@
                           <a:ea typeface="Arial" pitchFamily="34" charset="-122"/>
                           <a:cs typeface="Arial" pitchFamily="34" charset="-120"/>
                         </a:rPr>
-                        <a:t>Equipo Antimarrulla</a:t>
+                        <a:t>Granite (entorno del hospital)</a:t>
                       </a:r>
                       <a:endParaRPr lang="en-US" sz="1200" dirty="0">
                         <a:latin typeface="Arial" charset="0"/>
@@ -6258,15 +6258,15 @@
                         <a:buNone/>
                       </a:pPr>
                       <a:r>
-                        <a:rPr lang="en-US" sz="1200" b="1" dirty="0">
+                        <a:rPr lang="en-US" sz="1200" dirty="0">
                           <a:solidFill>
-                            <a:schemeClr val="accent2"/>
+                            <a:schemeClr val="bg2"/>
                           </a:solidFill>
                           <a:latin typeface="Arial" pitchFamily="34" charset="0"/>
                           <a:ea typeface="Arial" pitchFamily="34" charset="-122"/>
                           <a:cs typeface="Arial" pitchFamily="34" charset="-120"/>
                         </a:rPr>
-                        <a:t>Nada</a:t>
+                        <a:t>Solo lo que el hospital le pase</a:t>
                       </a:r>
                       <a:endParaRPr lang="en-US" sz="1200" dirty="0">
                         <a:latin typeface="Arial" charset="0"/>
@@ -6323,15 +6323,15 @@
                         <a:buNone/>
                       </a:pPr>
                       <a:r>
-                        <a:rPr lang="en-US" sz="1200" b="1" dirty="0">
+                        <a:rPr lang="en-US" sz="1200" dirty="0">
                           <a:solidFill>
-                            <a:schemeClr val="accent2"/>
+                            <a:schemeClr val="bg2"/>
                           </a:solidFill>
                           <a:latin typeface="Arial" pitchFamily="34" charset="0"/>
                           <a:ea typeface="Arial" pitchFamily="34" charset="-122"/>
                           <a:cs typeface="Arial" pitchFamily="34" charset="-120"/>
                         </a:rPr>
-                        <a:t>Nada</a:t>
+                        <a:t>Resultado descifrado</a:t>
                       </a:r>
                       <a:endParaRPr lang="en-US" sz="1200" dirty="0">
                         <a:latin typeface="Arial" charset="0"/>
@@ -8281,7 +8281,7 @@
                 <a:ea typeface="Courier New" pitchFamily="34" charset="-122"/>
                 <a:cs typeface="Courier New" pitchFamily="34" charset="-120"/>
               </a:rPr>
-              <a:t>edad         </a:t>
+              <a:t>Age          </a:t>
             </a:r>
             <a:pPr indent="0" marL="0">
               <a:buNone/>
@@ -8334,7 +8334,7 @@
                 <a:ea typeface="Courier New" pitchFamily="34" charset="-122"/>
                 <a:cs typeface="Courier New" pitchFamily="34" charset="-120"/>
               </a:rPr>
-              <a:t>imc          </a:t>
+              <a:t>BMI          </a:t>
             </a:r>
             <a:pPr indent="0" marL="0">
               <a:buNone/>
@@ -8387,7 +8387,7 @@
                 <a:ea typeface="Courier New" pitchFamily="34" charset="-122"/>
                 <a:cs typeface="Courier New" pitchFamily="34" charset="-120"/>
               </a:rPr>
-              <a:t>presión      </a:t>
+              <a:t>HighBP       </a:t>
             </a:r>
             <a:pPr indent="0" marL="0">
               <a:buNone/>
@@ -8440,7 +8440,7 @@
                 <a:ea typeface="Courier New" pitchFamily="34" charset="-122"/>
                 <a:cs typeface="Courier New" pitchFamily="34" charset="-120"/>
               </a:rPr>
-              <a:t>glucosa_hist </a:t>
+              <a:t>HighChol     </a:t>
             </a:r>
             <a:pPr indent="0" marL="0">
               <a:buNone/>
@@ -8493,7 +8493,7 @@
                 <a:ea typeface="Courier New" pitchFamily="34" charset="-122"/>
                 <a:cs typeface="Courier New" pitchFamily="34" charset="-120"/>
               </a:rPr>
-              <a:t>actividad    </a:t>
+              <a:t>PhysActivity </a:t>
             </a:r>
             <a:pPr indent="0" marL="0">
               <a:buNone/>
@@ -8546,7 +8546,7 @@
                 <a:ea typeface="Courier New" pitchFamily="34" charset="-122"/>
                 <a:cs typeface="Courier New" pitchFamily="34" charset="-120"/>
               </a:rPr>
-              <a:t>riesgo       </a:t>
+              <a:t>Enc(logit)   </a:t>
             </a:r>
             <a:pPr indent="0" marL="0">
               <a:buNone/>
@@ -10600,7 +10600,7 @@
                   <a:schemeClr val="accent5"/>
                 </a:solidFill>
               </a:rPr>
-              <a:t>RIESGO #1 DE LOS JUECES, CONTROLADO</a:t>
+              <a:t>CÓMO LO MEDIMOS · RESULTADOS EN VIVO EN LA DEMO</a:t>
             </a:r>
             <a:endParaRPr lang="en-US" sz="1100" dirty="0"/>
           </a:p>
@@ -10608,7 +10608,7 @@
       </p:sp>
       <p:sp>
         <p:nvSpPr>
-          <p:cNvPr id="33" name="Ruta garantizada · Paillier"/>
+          <p:cNvPr id="33" name="Métricas"/>
           <p:cNvSpPr/>
           <p:nvPr/>
         </p:nvSpPr>
@@ -10639,7 +10639,7 @@
       </p:sp>
       <p:sp>
         <p:nvSpPr>
-          <p:cNvPr id="34" name="Ruta garantizada · Paillier círculo"/>
+          <p:cNvPr id="34" name="Métricas círculo"/>
           <p:cNvSpPr/>
           <p:nvPr/>
         </p:nvSpPr>
@@ -10659,7 +10659,7 @@
       </p:sp>
       <p:pic>
         <p:nvPicPr>
-          <p:cNvPr id="35" name="Ruta garantizada · Paillier ícono" descr="preencoded.png">    </p:cNvPr>
+          <p:cNvPr id="35" name="Métricas ícono" descr="preencoded.png">    </p:cNvPr>
           <p:cNvPicPr>
             <a:picLocks noChangeAspect="1"/>
           </p:cNvPicPr>
@@ -10711,7 +10711,7 @@
                   <a:schemeClr val="bg1"/>
                 </a:solidFill>
               </a:rPr>
-              <a:t>Ruta garantizada · Paillier</a:t>
+              <a:t>Métricas</a:t>
             </a:r>
             <a:endParaRPr lang="en-US" sz="1500" dirty="0"/>
           </a:p>
@@ -10747,7 +10747,7 @@
                   <a:schemeClr val="bg2"/>
                 </a:solidFill>
               </a:rPr>
-              <a:t>python-paillier es Python puro: corre en s390x sin compilar nada. Basta para una regresión logística.</a:t>
+              <a:t>AUC, AUC-PR, sensibilidad y especificidad, calibración, error numérico claro vs. cifrado y latencia en LinuxONE.</a:t>
             </a:r>
             <a:endParaRPr lang="en-US" sz="1200" dirty="0"/>
           </a:p>
@@ -10755,7 +10755,7 @@
       </p:sp>
       <p:sp>
         <p:nvSpPr>
-          <p:cNvPr id="38" name="Ruta ambiciosa · CKKS"/>
+          <p:cNvPr id="38" name="Límites"/>
           <p:cNvSpPr/>
           <p:nvPr/>
         </p:nvSpPr>
@@ -10786,7 +10786,7 @@
       </p:sp>
       <p:sp>
         <p:nvSpPr>
-          <p:cNvPr id="39" name="Ruta ambiciosa · CKKS círculo"/>
+          <p:cNvPr id="39" name="Límites círculo"/>
           <p:cNvSpPr/>
           <p:nvPr/>
         </p:nvSpPr>
@@ -10806,7 +10806,7 @@
       </p:sp>
       <p:pic>
         <p:nvPicPr>
-          <p:cNvPr id="40" name="Ruta ambiciosa · CKKS ícono" descr="preencoded.png">    </p:cNvPr>
+          <p:cNvPr id="40" name="Límites ícono" descr="preencoded.png">    </p:cNvPr>
           <p:cNvPicPr>
             <a:picLocks noChangeAspect="1"/>
           </p:cNvPicPr>
@@ -10858,7 +10858,7 @@
                   <a:schemeClr val="bg1"/>
                 </a:solidFill>
               </a:rPr>
-              <a:t>Ruta ambiciosa · CKKS</a:t>
+              <a:t>Límites</a:t>
             </a:r>
             <a:endParaRPr lang="en-US" sz="1500" dirty="0"/>
           </a:p>
@@ -10894,7 +10894,7 @@
                   <a:schemeClr val="bg2"/>
                 </a:solidFill>
               </a:rPr>
-              <a:t>TenSEAL u OpenFHE si compilan en LinuxONE en la hora 2. Si no, nos quedamos en Paillier.</a:t>
+              <a:t>Datos de EE. UU. y diagnóstico declarado: es una prueba técnica. La validamos con adultos mexicanos de ENSANUT.</a:t>
             </a:r>
             <a:endParaRPr lang="en-US" sz="1200" dirty="0"/>
           </a:p>

</xml_diff>

<commit_message>
decisiones post-auditoría: E5 y CKKS como extra, misma VM con frontera declarada, uso de IA en README y correos
</commit_message>
<xml_diff>
--- a/submission/Los_Antimarrulla_Pitch_Tamizaje.pptx
+++ b/submission/Los_Antimarrulla_Pitch_Tamizaje.pptx
@@ -114,30 +114,30 @@
   <p:extLst>
     <p:ext uri="{521415D9-36F7-43E2-AB2F-B90AF26B5E84}">
       <p14:sectionLst xmlns:p14="http://schemas.microsoft.com/office/powerpoint/2010/main">
-        <p14:section name="Portada" id="{9cb336fb-08bc-168b-953a-8a0176050050}">
+        <p14:section name="Portada" id="{265c1457-b28e-8d28-27e5-a0b7e4314ce2}">
           <p14:sldIdLst>
             <p14:sldId id="256"/>
           </p14:sldIdLst>
         </p14:section>
-        <p14:section name="Problema y solución" id="{b6938fb9-8e33-66e9-8e5d-fec9ab9adb74}">
+        <p14:section name="Problema y solución" id="{dd372374-3ad3-1f55-d037-84b683c92c9b}">
           <p14:sldIdLst>
             <p14:sldId id="257"/>
             <p14:sldId id="258"/>
           </p14:sldIdLst>
         </p14:section>
-        <p14:section name="Tecnología" id="{2bde8551-23af-d9fd-02ae-67e149905b0b}">
+        <p14:section name="Tecnología" id="{aeaeb5b8-516f-51b0-ba57-1d9615988a73}">
           <p14:sldIdLst>
             <p14:sldId id="259"/>
             <p14:sldId id="260"/>
           </p14:sldIdLst>
         </p14:section>
-        <p14:section name="Demo y datos" id="{071dd8da-afd0-753d-3256-80c53e23b3e9}">
+        <p14:section name="Demo y datos" id="{d0e5add9-0359-cf56-e01c-54bd86904226}">
           <p14:sldIdLst>
             <p14:sldId id="261"/>
             <p14:sldId id="262"/>
           </p14:sldIdLst>
         </p14:section>
-        <p14:section name="Impacto y cierre" id="{0693b817-cfa8-e0a4-4402-85181226d90c}">
+        <p14:section name="Impacto y cierre" id="{041b4354-e434-9079-19dd-4e6be1b101b0}">
           <p14:sldIdLst>
             <p14:sldId id="263"/>
           </p14:sldIdLst>
@@ -898,7 +898,7 @@
           <a:p>
             <a:r>
               <a:rPr lang="en-US" dirty="0"/>
-              <a:t>Todo corre en LinuxONE, en dos contenedores Docker. El del hospital guarda la llave privada, cifra, descifra y usa Granite para explicar. El servicio de riesgo nunca tiene la llave: solo hace aritmética homomórfica, que son exponenciaciones con enteros enormes, justo el tipo de cómputo pesado y seguro para el que está hecho IBM Z. Mostrar aquí la instancia LinuxONE y los dos contenedores corriendo (requisito del video).</a:t>
+              <a:t>Todo corre en LinuxONE, en dos contenedores Docker. El del hospital guarda la llave privada, cifra, descifra y usa Granite para explicar. El servicio de riesgo nunca tiene la llave: solo hace aritmética homomórfica, que son exponenciaciones con enteros enormes, justo el tipo de cómputo pesado y seguro para el que está hecho IBM Z. En la demo los dos contenedores corren en la misma VM, así que quien la administra queda dentro de la frontera de confianza; en producción, el contenedor del hospital correría en sus propias instalaciones. Mostrar aquí la instancia LinuxONE y los dos contenedores corriendo (requisito del video).</a:t>
             </a:r>
             <a:endParaRPr lang="en-US" dirty="0"/>
           </a:p>
@@ -6665,7 +6665,57 @@
       </p:sp>
       <p:sp>
         <p:nvSpPr>
-          <p:cNvPr id="9" name="IBM LinuxONE"/>
+          <p:cNvPr id="9" name="Text 6"/>
+          <p:cNvSpPr txBox="1"/>
+          <p:nvPr/>
+        </p:nvSpPr>
+        <p:spPr>
+          <a:xfrm>
+            <a:off x="548640" y="4160520"/>
+            <a:ext cx="1645920" cy="1554480"/>
+          </a:xfrm>
+          <a:prstGeom prst="rect">
+            <a:avLst/>
+          </a:prstGeom>
+          <a:noFill/>
+          <a:ln/>
+        </p:spPr>
+        <p:txBody>
+          <a:bodyPr wrap="square" lIns="0" tIns="0" rIns="0" bIns="0" rtlCol="0" anchor="t"/>
+          <a:lstStyle/>
+          <a:p>
+            <a:pPr indent="0" marL="0">
+              <a:buNone/>
+            </a:pPr>
+            <a:r>
+              <a:rPr lang="en-US" sz="900" b="1" dirty="0">
+                <a:solidFill>
+                  <a:schemeClr val="accent5"/>
+                </a:solidFill>
+              </a:rPr>
+              <a:t>En la demo</a:t>
+            </a:r>
+            <a:endParaRPr lang="en-US" sz="900" dirty="0"/>
+          </a:p>
+          <a:p>
+            <a:pPr indent="0" marL="0">
+              <a:buNone/>
+            </a:pPr>
+            <a:r>
+              <a:rPr lang="en-US" sz="900" dirty="0">
+                <a:solidFill>
+                  <a:schemeClr val="bg2"/>
+                </a:solidFill>
+              </a:rPr>
+              <a:t>ambos contenedores corren en la misma VM; quien la administra queda dentro de la frontera de confianza. En producción, el del hospital corre en sus instalaciones.</a:t>
+            </a:r>
+            <a:endParaRPr lang="en-US" sz="900" dirty="0"/>
+          </a:p>
+        </p:txBody>
+      </p:sp>
+      <p:sp>
+        <p:nvSpPr>
+          <p:cNvPr id="10" name="IBM LinuxONE"/>
           <p:cNvSpPr/>
           <p:nvPr/>
         </p:nvSpPr>
@@ -6694,7 +6744,7 @@
       </p:sp>
       <p:sp>
         <p:nvSpPr>
-          <p:cNvPr id="10" name="LinuxONE círculo"/>
+          <p:cNvPr id="11" name="LinuxONE círculo"/>
           <p:cNvSpPr/>
           <p:nvPr/>
         </p:nvSpPr>
@@ -6714,7 +6764,7 @@
       </p:sp>
       <p:pic>
         <p:nvPicPr>
-          <p:cNvPr id="11" name="LinuxONE ícono" descr="preencoded.png">    </p:cNvPr>
+          <p:cNvPr id="12" name="LinuxONE ícono" descr="preencoded.png">    </p:cNvPr>
           <p:cNvPicPr>
             <a:picLocks noChangeAspect="1"/>
           </p:cNvPicPr>
@@ -6738,7 +6788,7 @@
       </p:pic>
       <p:sp>
         <p:nvSpPr>
-          <p:cNvPr id="12" name="Text 8"/>
+          <p:cNvPr id="13" name="Text 9"/>
           <p:cNvSpPr txBox="1"/>
           <p:nvPr/>
         </p:nvSpPr>
@@ -6774,7 +6824,7 @@
       </p:sp>
       <p:sp>
         <p:nvSpPr>
-          <p:cNvPr id="13" name="Text 9"/>
+          <p:cNvPr id="14" name="Text 10"/>
           <p:cNvSpPr txBox="1"/>
           <p:nvPr/>
         </p:nvSpPr>
@@ -6810,7 +6860,7 @@
       </p:sp>
       <p:sp>
         <p:nvSpPr>
-          <p:cNvPr id="14" name="Contenedor del hospital"/>
+          <p:cNvPr id="15" name="Contenedor del hospital"/>
           <p:cNvSpPr/>
           <p:nvPr/>
         </p:nvSpPr>
@@ -6839,7 +6889,7 @@
       </p:sp>
       <p:sp>
         <p:nvSpPr>
-          <p:cNvPr id="15" name="Text 11"/>
+          <p:cNvPr id="16" name="Text 12"/>
           <p:cNvSpPr txBox="1"/>
           <p:nvPr/>
         </p:nvSpPr>
@@ -6875,7 +6925,7 @@
       </p:sp>
       <p:sp>
         <p:nvSpPr>
-          <p:cNvPr id="16" name="Llave privada Paillier"/>
+          <p:cNvPr id="17" name="Llave privada Paillier"/>
           <p:cNvSpPr/>
           <p:nvPr/>
         </p:nvSpPr>
@@ -6899,7 +6949,7 @@
       </p:sp>
       <p:sp>
         <p:nvSpPr>
-          <p:cNvPr id="17" name="Text 13"/>
+          <p:cNvPr id="18" name="Text 14"/>
           <p:cNvSpPr txBox="1"/>
           <p:nvPr/>
         </p:nvSpPr>
@@ -6935,7 +6985,7 @@
       </p:sp>
       <p:sp>
         <p:nvSpPr>
-          <p:cNvPr id="18" name="Text 14"/>
+          <p:cNvPr id="19" name="Text 15"/>
           <p:cNvSpPr txBox="1"/>
           <p:nvPr/>
         </p:nvSpPr>
@@ -6971,7 +7021,7 @@
       </p:sp>
       <p:sp>
         <p:nvSpPr>
-          <p:cNvPr id="19" name="Cifrar y descifrar"/>
+          <p:cNvPr id="20" name="Cifrar y descifrar"/>
           <p:cNvSpPr/>
           <p:nvPr/>
         </p:nvSpPr>
@@ -6995,7 +7045,7 @@
       </p:sp>
       <p:sp>
         <p:nvSpPr>
-          <p:cNvPr id="20" name="Text 16"/>
+          <p:cNvPr id="21" name="Text 17"/>
           <p:cNvSpPr txBox="1"/>
           <p:nvPr/>
         </p:nvSpPr>
@@ -7031,7 +7081,7 @@
       </p:sp>
       <p:sp>
         <p:nvSpPr>
-          <p:cNvPr id="21" name="Text 17"/>
+          <p:cNvPr id="22" name="Text 18"/>
           <p:cNvSpPr txBox="1"/>
           <p:nvPr/>
         </p:nvSpPr>
@@ -7067,7 +7117,7 @@
       </p:sp>
       <p:sp>
         <p:nvSpPr>
-          <p:cNvPr id="22" name="Granite · llama.cpp"/>
+          <p:cNvPr id="23" name="Granite · llama.cpp"/>
           <p:cNvSpPr/>
           <p:nvPr/>
         </p:nvSpPr>
@@ -7091,7 +7141,7 @@
       </p:sp>
       <p:sp>
         <p:nvSpPr>
-          <p:cNvPr id="23" name="Text 19"/>
+          <p:cNvPr id="24" name="Text 20"/>
           <p:cNvSpPr txBox="1"/>
           <p:nvPr/>
         </p:nvSpPr>
@@ -7127,7 +7177,7 @@
       </p:sp>
       <p:sp>
         <p:nvSpPr>
-          <p:cNvPr id="24" name="Text 20"/>
+          <p:cNvPr id="25" name="Text 21"/>
           <p:cNvSpPr txBox="1"/>
           <p:nvPr/>
         </p:nvSpPr>
@@ -7163,7 +7213,7 @@
       </p:sp>
       <p:sp>
         <p:nvSpPr>
-          <p:cNvPr id="25" name="Servicio de riesgo"/>
+          <p:cNvPr id="26" name="Servicio de riesgo"/>
           <p:cNvSpPr/>
           <p:nvPr/>
         </p:nvSpPr>
@@ -7192,7 +7242,7 @@
       </p:sp>
       <p:sp>
         <p:nvSpPr>
-          <p:cNvPr id="26" name="Text 22"/>
+          <p:cNvPr id="27" name="Text 23"/>
           <p:cNvSpPr txBox="1"/>
           <p:nvPr/>
         </p:nvSpPr>
@@ -7228,7 +7278,7 @@
       </p:sp>
       <p:sp>
         <p:nvSpPr>
-          <p:cNvPr id="27" name="Modelo logístico"/>
+          <p:cNvPr id="28" name="Modelo logístico"/>
           <p:cNvSpPr/>
           <p:nvPr/>
         </p:nvSpPr>
@@ -7252,7 +7302,7 @@
       </p:sp>
       <p:sp>
         <p:nvSpPr>
-          <p:cNvPr id="28" name="Text 24"/>
+          <p:cNvPr id="29" name="Text 25"/>
           <p:cNvSpPr txBox="1"/>
           <p:nvPr/>
         </p:nvSpPr>
@@ -7288,7 +7338,7 @@
       </p:sp>
       <p:sp>
         <p:nvSpPr>
-          <p:cNvPr id="29" name="Text 25"/>
+          <p:cNvPr id="30" name="Text 26"/>
           <p:cNvSpPr txBox="1"/>
           <p:nvPr/>
         </p:nvSpPr>
@@ -7324,7 +7374,7 @@
       </p:sp>
       <p:sp>
         <p:nvSpPr>
-          <p:cNvPr id="30" name="Aritmética homomórfica"/>
+          <p:cNvPr id="31" name="Aritmética homomórfica"/>
           <p:cNvSpPr/>
           <p:nvPr/>
         </p:nvSpPr>
@@ -7348,7 +7398,7 @@
       </p:sp>
       <p:sp>
         <p:nvSpPr>
-          <p:cNvPr id="31" name="Text 27"/>
+          <p:cNvPr id="32" name="Text 28"/>
           <p:cNvSpPr txBox="1"/>
           <p:nvPr/>
         </p:nvSpPr>
@@ -7384,7 +7434,7 @@
       </p:sp>
       <p:sp>
         <p:nvSpPr>
-          <p:cNvPr id="32" name="Text 28"/>
+          <p:cNvPr id="33" name="Text 29"/>
           <p:cNvSpPr txBox="1"/>
           <p:nvPr/>
         </p:nvSpPr>
@@ -7420,7 +7470,7 @@
       </p:sp>
       <p:sp>
         <p:nvSpPr>
-          <p:cNvPr id="33" name="Bóveda cifrada"/>
+          <p:cNvPr id="34" name="Bóveda cifrada"/>
           <p:cNvSpPr/>
           <p:nvPr/>
         </p:nvSpPr>
@@ -7444,7 +7494,7 @@
       </p:sp>
       <p:sp>
         <p:nvSpPr>
-          <p:cNvPr id="34" name="Text 30"/>
+          <p:cNvPr id="35" name="Text 31"/>
           <p:cNvSpPr txBox="1"/>
           <p:nvPr/>
         </p:nvSpPr>
@@ -7480,7 +7530,7 @@
       </p:sp>
       <p:sp>
         <p:nvSpPr>
-          <p:cNvPr id="35" name="Text 31"/>
+          <p:cNvPr id="36" name="Text 32"/>
           <p:cNvSpPr txBox="1"/>
           <p:nvPr/>
         </p:nvSpPr>
@@ -7516,7 +7566,7 @@
       </p:sp>
       <p:sp>
         <p:nvSpPr>
-          <p:cNvPr id="36" name="flecha"/>
+          <p:cNvPr id="37" name="flecha"/>
           <p:cNvSpPr/>
           <p:nvPr/>
         </p:nvSpPr>
@@ -7540,7 +7590,7 @@
       </p:sp>
       <p:sp>
         <p:nvSpPr>
-          <p:cNvPr id="37" name="flecha regreso"/>
+          <p:cNvPr id="38" name="flecha regreso"/>
           <p:cNvSpPr/>
           <p:nvPr/>
         </p:nvSpPr>
@@ -7564,7 +7614,7 @@
       </p:sp>
       <p:sp>
         <p:nvSpPr>
-          <p:cNvPr id="38" name="Text 34"/>
+          <p:cNvPr id="39" name="Text 35"/>
           <p:cNvSpPr txBox="1"/>
           <p:nvPr/>
         </p:nvSpPr>
@@ -7600,7 +7650,7 @@
       </p:sp>
       <p:sp>
         <p:nvSpPr>
-          <p:cNvPr id="39" name="Cómputo pesado, en serio círculo"/>
+          <p:cNvPr id="40" name="Cómputo pesado, en serio círculo"/>
           <p:cNvSpPr/>
           <p:nvPr/>
         </p:nvSpPr>
@@ -7620,7 +7670,7 @@
       </p:sp>
       <p:pic>
         <p:nvPicPr>
-          <p:cNvPr id="40" name="Cómputo pesado, en serio ícono" descr="preencoded.png">    </p:cNvPr>
+          <p:cNvPr id="41" name="Cómputo pesado, en serio ícono" descr="preencoded.png">    </p:cNvPr>
           <p:cNvPicPr>
             <a:picLocks noChangeAspect="1"/>
           </p:cNvPicPr>
@@ -7644,7 +7694,7 @@
       </p:pic>
       <p:sp>
         <p:nvSpPr>
-          <p:cNvPr id="41" name="Text 36"/>
+          <p:cNvPr id="42" name="Text 37"/>
           <p:cNvSpPr txBox="1"/>
           <p:nvPr/>
         </p:nvSpPr>
@@ -7680,7 +7730,7 @@
       </p:sp>
       <p:sp>
         <p:nvSpPr>
-          <p:cNvPr id="42" name="Text 37"/>
+          <p:cNvPr id="43" name="Text 38"/>
           <p:cNvSpPr txBox="1"/>
           <p:nvPr/>
         </p:nvSpPr>
@@ -7716,7 +7766,7 @@
       </p:sp>
       <p:sp>
         <p:nvSpPr>
-          <p:cNvPr id="43" name="Seguridad de nivel bancario círculo"/>
+          <p:cNvPr id="44" name="Seguridad de nivel bancario círculo"/>
           <p:cNvSpPr/>
           <p:nvPr/>
         </p:nvSpPr>
@@ -7736,7 +7786,7 @@
       </p:sp>
       <p:pic>
         <p:nvPicPr>
-          <p:cNvPr id="44" name="Seguridad de nivel bancario ícono" descr="preencoded.png">    </p:cNvPr>
+          <p:cNvPr id="45" name="Seguridad de nivel bancario ícono" descr="preencoded.png">    </p:cNvPr>
           <p:cNvPicPr>
             <a:picLocks noChangeAspect="1"/>
           </p:cNvPicPr>
@@ -7760,7 +7810,7 @@
       </p:pic>
       <p:sp>
         <p:nvSpPr>
-          <p:cNvPr id="45" name="Text 39"/>
+          <p:cNvPr id="46" name="Text 40"/>
           <p:cNvSpPr txBox="1"/>
           <p:nvPr/>
         </p:nvSpPr>
@@ -7796,7 +7846,7 @@
       </p:sp>
       <p:sp>
         <p:nvSpPr>
-          <p:cNvPr id="46" name="Text 40"/>
+          <p:cNvPr id="47" name="Text 41"/>
           <p:cNvSpPr txBox="1"/>
           <p:nvPr/>
         </p:nvSpPr>
@@ -7832,7 +7882,7 @@
       </p:sp>
       <p:sp>
         <p:nvSpPr>
-          <p:cNvPr id="47" name="Escala por lotes círculo"/>
+          <p:cNvPr id="48" name="Escala por lotes círculo"/>
           <p:cNvSpPr/>
           <p:nvPr/>
         </p:nvSpPr>
@@ -7852,7 +7902,7 @@
       </p:sp>
       <p:pic>
         <p:nvPicPr>
-          <p:cNvPr id="48" name="Escala por lotes ícono" descr="preencoded.png">    </p:cNvPr>
+          <p:cNvPr id="49" name="Escala por lotes ícono" descr="preencoded.png">    </p:cNvPr>
           <p:cNvPicPr>
             <a:picLocks noChangeAspect="1"/>
           </p:cNvPicPr>
@@ -7876,7 +7926,7 @@
       </p:pic>
       <p:sp>
         <p:nvSpPr>
-          <p:cNvPr id="49" name="Text 42"/>
+          <p:cNvPr id="50" name="Text 43"/>
           <p:cNvSpPr txBox="1"/>
           <p:nvPr/>
         </p:nvSpPr>
@@ -7912,7 +7962,7 @@
       </p:sp>
       <p:sp>
         <p:nvSpPr>
-          <p:cNvPr id="50" name="Text 43"/>
+          <p:cNvPr id="51" name="Text 44"/>
           <p:cNvSpPr txBox="1"/>
           <p:nvPr/>
         </p:nvSpPr>
@@ -7948,7 +7998,7 @@
       </p:sp>
       <p:sp>
         <p:nvSpPr>
-          <p:cNvPr id="51" name="Text 44"/>
+          <p:cNvPr id="52" name="Text 45"/>
           <p:cNvSpPr txBox="1"/>
           <p:nvPr/>
         </p:nvSpPr>

</xml_diff>

<commit_message>
auditoría 2: horario con descansos, CKKS como extra, contrato numérico, alcance de la privacidad, ENSANUT pendiente, datos reproducibles desde cero y pasos de envío
</commit_message>
<xml_diff>
--- a/submission/Los_Antimarrulla_Pitch_Tamizaje.pptx
+++ b/submission/Los_Antimarrulla_Pitch_Tamizaje.pptx
@@ -114,30 +114,30 @@
   <p:extLst>
     <p:ext uri="{521415D9-36F7-43E2-AB2F-B90AF26B5E84}">
       <p14:sectionLst xmlns:p14="http://schemas.microsoft.com/office/powerpoint/2010/main">
-        <p14:section name="Portada" id="{265c1457-b28e-8d28-27e5-a0b7e4314ce2}">
+        <p14:section name="Portada" id="{85faf5c1-435b-20e1-1fa6-392b2bace550}">
           <p14:sldIdLst>
             <p14:sldId id="256"/>
           </p14:sldIdLst>
         </p14:section>
-        <p14:section name="Problema y solución" id="{dd372374-3ad3-1f55-d037-84b683c92c9b}">
+        <p14:section name="Problema y solución" id="{68e8c68e-7c3a-1108-92d4-b1dc7cdb1753}">
           <p14:sldIdLst>
             <p14:sldId id="257"/>
             <p14:sldId id="258"/>
           </p14:sldIdLst>
         </p14:section>
-        <p14:section name="Tecnología" id="{aeaeb5b8-516f-51b0-ba57-1d9615988a73}">
+        <p14:section name="Tecnología" id="{968a082a-c61e-ab8c-d09f-bd3b3b40c4c5}">
           <p14:sldIdLst>
             <p14:sldId id="259"/>
             <p14:sldId id="260"/>
           </p14:sldIdLst>
         </p14:section>
-        <p14:section name="Demo y datos" id="{d0e5add9-0359-cf56-e01c-54bd86904226}">
+        <p14:section name="Demo y datos" id="{ebc1c4c4-e742-2450-812e-5ae93b71c498}">
           <p14:sldIdLst>
             <p14:sldId id="261"/>
             <p14:sldId id="262"/>
           </p14:sldIdLst>
         </p14:section>
-        <p14:section name="Impacto y cierre" id="{041b4354-e434-9079-19dd-4e6be1b101b0}">
+        <p14:section name="Impacto y cierre" id="{e7784cba-d04d-8359-4ddc-7f5ce4619a34}">
           <p14:sldIdLst>
             <p14:sldId id="263"/>
           </p14:sldIdLst>
@@ -722,7 +722,7 @@
           <a:p>
             <a:r>
               <a:rPr lang="en-US" dirty="0"/>
-              <a:t>Así funciona: el hospital cifra los 21 indicadores del paciente y se queda con la llave. LinuxONE calcula el riesgo sobre los números cifrados, sin llave. El resultado regresa cifrado; solo el hospital lo abre, y Granite le explica el resultado al paciente en lenguaje claro. Es tamizaje: decide a quién hacerle una prueba de glucosa primero.</a:t>
+              <a:t>El hospital cifra los 21 indicadores del paciente y se queda con la llave. LinuxONE calcula el riesgo sobre números cifrados; solo el hospital abre el resultado y Granite lo explica. Es tamizaje: decide a quién hacerle primero una prueba de glucosa. (Alcance: el servicio de riesgo solo recibe cifrados; en la demo, quien administra la VM queda dentro del entorno de confianza y usamos pacientes sintéticos.)</a:t>
             </a:r>
             <a:endParaRPr lang="en-US" dirty="0"/>
           </a:p>
@@ -810,7 +810,7 @@
           <a:p>
             <a:r>
               <a:rPr lang="en-US" dirty="0"/>
-              <a:t>Este es el corazón del Reto 2. Usamos cifrado homomórfico Paillier: multiplicar cifrados suma los valores y elevar un cifrado a una potencia lo multiplica. Con eso, el servidor calcula el puntaje de una regresión logística sin descifrar nada. Además, TLS 1.3 en tránsito y AES-256-GCM acelerado por CPACF en reposo. El servicio de riesgo nunca ve datos en claro: la llave se queda con el hospital, y quien administre el entorno del hospital es parte de la frontera de confianza. ANTES DE PRESENTAR: capturar 'openssl speed -evp aes-256-gcm' en la VM como evidencia.</a:t>
+              <a:t>Usamos cifrado homomórfico Paillier: multiplicar cifrados suma sus valores y elevarlos a una potencia los multiplica. Así el servidor calcula el puntaje del modelo sin descifrar nada. Además, TLS 1.3 en tránsito y AES-256-GCM en reposo. ANTES DE PRESENTAR: capturar lscpu, cpacfinfo y las versiones de OpenSSL (CLI y cryptography) como evidencia de CPACF.</a:t>
             </a:r>
             <a:endParaRPr lang="en-US" dirty="0"/>
           </a:p>
@@ -898,7 +898,7 @@
           <a:p>
             <a:r>
               <a:rPr lang="en-US" dirty="0"/>
-              <a:t>Todo corre en LinuxONE, en dos contenedores Docker. El del hospital guarda la llave privada, cifra, descifra y usa Granite para explicar. El servicio de riesgo nunca tiene la llave: solo hace aritmética homomórfica, que son exponenciaciones con enteros enormes, justo el tipo de cómputo pesado y seguro para el que está hecho IBM Z. En la demo los dos contenedores corren en la misma VM, así que quien la administra queda dentro de la frontera de confianza; en producción, el contenedor del hospital correría en sus propias instalaciones. Mostrar aquí la instancia LinuxONE y los dos contenedores corriendo (requisito del video).</a:t>
+              <a:t>Mostrar la terminal de la VM: uname -m → s390x, los dos contenedores corriendo y el modelo cargado. Todo corre en LinuxONE, en dos contenedores: el del hospital, con la llave, y el servicio de riesgo, sin ella. En la demo comparten VM; en producción, el del hospital vive en sus instalaciones. La aritmética homomórfica son exponenciaciones con enteros de miles de bits: cómputo pesado, justo para IBM Z.</a:t>
             </a:r>
             <a:endParaRPr lang="en-US" dirty="0"/>
           </a:p>
@@ -986,7 +986,7 @@
           <a:p>
             <a:r>
               <a:rPr lang="en-US" dirty="0"/>
-              <a:t>Demo en pantalla dividida. A la izquierda, lo que ve el servidor: solo números cifrados. A la derecha, lo que ve el hospital: el riesgo, los factores principales y la explicación de Granite. Abajo, métricas medidas en vivo en LinuxONE: el AUC en claro contra el cifrado, la latencia por paciente, el tamaño del cifrado y los pacientes por minuto.</a:t>
+              <a:t>Pantalla dividida. A la izquierda, lo que ve el servidor: solo números cifrados. A la derecha, lo que ve el hospital: el riesgo, los factores principales y la explicación de Granite. Abajo, medido en LinuxONE sobre [n] pacientes: el AUC en claro contra el cifrado [cifra real] y la latencia por paciente [cifra real].</a:t>
             </a:r>
             <a:endParaRPr lang="en-US" dirty="0"/>
           </a:p>
@@ -1074,7 +1074,7 @@
           <a:p>
             <a:r>
               <a:rPr lang="en-US" dirty="0"/>
-              <a:t>Entrenamos con datos públicos: 253,680 respuestas de la encuesta de salud de los CDC, con 21 indicadores. Los datos de pacientes reales solo llegan cifrados. Medimos AUC, AUC-PR, sensibilidad, especificidad, calibración y el error numérico entre claro y cifrado. Es una prueba técnica con datos de EE. UU.; la validamos con adultos mexicanos de ENSANUT.</a:t>
+              <a:t>Entrenamos con 253 mil registros públicos de los CDC. Los datos de pacientes solo llegan cifrados. (Es una prueba técnica con datos de EE. UU.; la evaluación externa exploratoria con ENSANUT está pendiente.)</a:t>
             </a:r>
             <a:endParaRPr lang="en-US" dirty="0"/>
           </a:p>
@@ -1162,7 +1162,7 @@
           <a:p>
             <a:r>
               <a:rPr lang="en-US" dirty="0"/>
-              <a:t>El impacto: tamizaje temprano para el tercio de personas que no sabe que tiene diabetes; en 2024, más de 11 mil hospitalizaciones por diabetes en la Secretaría de Salud incluyeron una amputación, confianza del paciente y cumplimiento con la ley de protección de datos, en un esquema que escala a otras enfermedades crónicas. La IA ve el riesgo; nadie ve al paciente. Somos Los Antimarrulla. Gracias.</a:t>
+              <a:t>En 2024, más de 11 mil hospitalizaciones por diabetes en la Secretaría de Salud incluyeron una amputación. Queremos detectar antes sin entregar un solo expediente. La IA ve el riesgo. Nadie ve al paciente. Gracias.</a:t>
             </a:r>
             <a:endParaRPr lang="en-US" dirty="0"/>
           </a:p>
@@ -3378,7 +3378,7 @@
                   <a:schemeClr val="bg1"/>
                 </a:solidFill>
               </a:rPr>
-              <a:t>El riesgo se calcula sobre datos que nadie puede leer</a:t>
+              <a:t>El riesgo se calcula sobre datos cifrados</a:t>
             </a:r>
             <a:endParaRPr lang="en-US" sz="3000" dirty="0"/>
           </a:p>
@@ -4038,7 +4038,7 @@
       </p:sp>
       <p:sp>
         <p:nvSpPr>
-          <p:cNvPr id="27" name="Cero exposición"/>
+          <p:cNvPr id="27" name="Solo cifrados"/>
           <p:cNvSpPr/>
           <p:nvPr/>
         </p:nvSpPr>
@@ -4069,7 +4069,7 @@
       </p:sp>
       <p:sp>
         <p:nvSpPr>
-          <p:cNvPr id="28" name="Cero exposición círculo"/>
+          <p:cNvPr id="28" name="Solo cifrados círculo"/>
           <p:cNvSpPr/>
           <p:nvPr/>
         </p:nvSpPr>
@@ -4089,7 +4089,7 @@
       </p:sp>
       <p:pic>
         <p:nvPicPr>
-          <p:cNvPr id="29" name="Cero exposición ícono" descr="preencoded.png">    </p:cNvPr>
+          <p:cNvPr id="29" name="Solo cifrados ícono" descr="preencoded.png">    </p:cNvPr>
           <p:cNvPicPr>
             <a:picLocks noChangeAspect="1"/>
           </p:cNvPicPr>
@@ -4141,7 +4141,7 @@
                   <a:schemeClr val="bg1"/>
                 </a:solidFill>
               </a:rPr>
-              <a:t>Cero exposición</a:t>
+              <a:t>Solo cifrados</a:t>
             </a:r>
             <a:endParaRPr lang="en-US" sz="1500" dirty="0"/>
           </a:p>
@@ -4177,7 +4177,7 @@
                   <a:schemeClr val="bg2"/>
                 </a:solidFill>
               </a:rPr>
-              <a:t>El servidor nunca ve edad, IMC, presión ni ningún otro dato</a:t>
+              <a:t>El servicio de riesgo nunca ve edad, IMC, presión ni ningún otro dato en claro</a:t>
             </a:r>
             <a:endParaRPr lang="en-US" sz="1200" dirty="0"/>
           </a:p>
@@ -4485,8 +4485,8 @@
         </p:nvSpPr>
         <p:spPr>
           <a:xfrm>
-            <a:off x="548640" y="5349240"/>
-            <a:ext cx="11091672" cy="548640"/>
+            <a:off x="548640" y="5120640"/>
+            <a:ext cx="11091672" cy="502920"/>
           </a:xfrm>
           <a:prstGeom prst="rect">
             <a:avLst/>
@@ -4521,6 +4521,42 @@
               <a:t>Nadie ve al paciente.</a:t>
             </a:r>
             <a:endParaRPr lang="en-US" sz="2600" dirty="0"/>
+          </a:p>
+        </p:txBody>
+      </p:sp>
+      <p:sp>
+        <p:nvSpPr>
+          <p:cNvPr id="43" name="Text 34"/>
+          <p:cNvSpPr txBox="1"/>
+          <p:nvPr/>
+        </p:nvSpPr>
+        <p:spPr>
+          <a:xfrm>
+            <a:off x="548640" y="5641848"/>
+            <a:ext cx="11091672" cy="411480"/>
+          </a:xfrm>
+          <a:prstGeom prst="rect">
+            <a:avLst/>
+          </a:prstGeom>
+          <a:noFill/>
+          <a:ln/>
+        </p:spPr>
+        <p:txBody>
+          <a:bodyPr wrap="square" lIns="0" tIns="0" rIns="0" bIns="0" rtlCol="0" anchor="t"/>
+          <a:lstStyle/>
+          <a:p>
+            <a:pPr indent="0" marL="0">
+              <a:buNone/>
+            </a:pPr>
+            <a:r>
+              <a:rPr lang="en-US" sz="1100" dirty="0">
+                <a:solidFill>
+                  <a:schemeClr val="bg2"/>
+                </a:solidFill>
+              </a:rPr>
+              <a:t>Alcance: el servicio de riesgo solo recibe cifrados. En la demo, hospital y servicio comparten una VM de LinuxONE: quien la administra queda dentro del entorno de confianza, y usamos solo pacientes sintéticos.</a:t>
+            </a:r>
+            <a:endParaRPr lang="en-US" sz="1100" dirty="0"/>
           </a:p>
         </p:txBody>
       </p:sp>
@@ -10797,7 +10833,7 @@
                   <a:schemeClr val="bg2"/>
                 </a:solidFill>
               </a:rPr>
-              <a:t>AUC, AUC-PR, sensibilidad y especificidad, calibración, error numérico claro vs. cifrado y latencia en LinuxONE.</a:t>
+              <a:t>AUC, AUC-PR, sensibilidad y especificidad con umbral fijado en validación, calibración, error claro vs. cifrado y latencia p50/p95, con el tamaño de la muestra.</a:t>
             </a:r>
             <a:endParaRPr lang="en-US" sz="1200" dirty="0"/>
           </a:p>
@@ -10944,7 +10980,7 @@
                   <a:schemeClr val="bg2"/>
                 </a:solidFill>
               </a:rPr>
-              <a:t>Datos de EE. UU. y diagnóstico declarado: es una prueba técnica. La validamos con adultos mexicanos de ENSANUT.</a:t>
+              <a:t>Datos de EE. UU. y diagnóstico declarado: es una prueba técnica. Evaluación externa exploratoria con ENSANUT: pendiente.</a:t>
             </a:r>
             <a:endParaRPr lang="en-US" sz="1200" dirty="0"/>
           </a:p>

</xml_diff>

<commit_message>
entrega: resultados reales en docs, deck y sitio (locales, no LinuxONE), guía para LinuxONE, declaración de IA completa y estado del plan con evidencia
</commit_message>
<xml_diff>
--- a/submission/Los_Antimarrulla_Pitch_Tamizaje.pptx
+++ b/submission/Los_Antimarrulla_Pitch_Tamizaje.pptx
@@ -114,30 +114,30 @@
   <p:extLst>
     <p:ext uri="{521415D9-36F7-43E2-AB2F-B90AF26B5E84}">
       <p14:sectionLst xmlns:p14="http://schemas.microsoft.com/office/powerpoint/2010/main">
-        <p14:section name="Portada" id="{85faf5c1-435b-20e1-1fa6-392b2bace550}">
+        <p14:section name="Portada" id="{03748e31-4eca-495e-bd01-836fbc85ee25}">
           <p14:sldIdLst>
             <p14:sldId id="256"/>
           </p14:sldIdLst>
         </p14:section>
-        <p14:section name="Problema y solución" id="{68e8c68e-7c3a-1108-92d4-b1dc7cdb1753}">
+        <p14:section name="Problema y solución" id="{58ce8105-2dd0-9662-3630-6e00c0a535e5}">
           <p14:sldIdLst>
             <p14:sldId id="257"/>
             <p14:sldId id="258"/>
           </p14:sldIdLst>
         </p14:section>
-        <p14:section name="Tecnología" id="{968a082a-c61e-ab8c-d09f-bd3b3b40c4c5}">
+        <p14:section name="Tecnología" id="{6b1cfbf7-d3d9-cb28-765c-fb7a7f219145}">
           <p14:sldIdLst>
             <p14:sldId id="259"/>
             <p14:sldId id="260"/>
           </p14:sldIdLst>
         </p14:section>
-        <p14:section name="Demo y datos" id="{ebc1c4c4-e742-2450-812e-5ae93b71c498}">
+        <p14:section name="Demo y datos" id="{d1f72b02-9b6c-2798-49f8-669a5c00bcbd}">
           <p14:sldIdLst>
             <p14:sldId id="261"/>
             <p14:sldId id="262"/>
           </p14:sldIdLst>
         </p14:section>
-        <p14:section name="Impacto y cierre" id="{e7784cba-d04d-8359-4ddc-7f5ce4619a34}">
+        <p14:section name="Impacto y cierre" id="{24f8c381-0d52-e82b-77d9-010db1d541b6}">
           <p14:sldIdLst>
             <p14:sldId id="263"/>
           </p14:sldIdLst>
@@ -722,7 +722,7 @@
           <a:p>
             <a:r>
               <a:rPr lang="en-US" dirty="0"/>
-              <a:t>El hospital cifra los 21 indicadores del paciente y se queda con la llave. LinuxONE calcula el riesgo sobre números cifrados; solo el hospital abre el resultado y Granite lo explica. Es tamizaje: decide a quién hacerle primero una prueba de glucosa. (Alcance: el servicio de riesgo solo recibe cifrados; en la demo, quien administra la VM queda dentro del entorno de confianza y usamos pacientes sintéticos.)</a:t>
+              <a:t>El hospital cifra los 21 indicadores del paciente y se queda con la llave. LinuxONE calcula el riesgo sobre números cifrados; solo el hospital abre el resultado y ve los factores que más pesan. Es tamizaje: decide a quién hacerle primero una prueba de glucosa. (Alcance: el servicio de riesgo solo recibe cifrados; en la demo, quien administra la VM queda dentro del entorno de confianza y usamos pacientes sintéticos.)</a:t>
             </a:r>
             <a:endParaRPr lang="en-US" dirty="0"/>
           </a:p>
@@ -898,7 +898,7 @@
           <a:p>
             <a:r>
               <a:rPr lang="en-US" dirty="0"/>
-              <a:t>Mostrar la terminal de la VM: uname -m → s390x, los dos contenedores corriendo y el modelo cargado. Todo corre en LinuxONE, en dos contenedores: el del hospital, con la llave, y el servicio de riesgo, sin ella. En la demo comparten VM; en producción, el del hospital vive en sus instalaciones. La aritmética homomórfica son exponenciaciones con enteros de miles de bits: cómputo pesado, justo para IBM Z.</a:t>
+              <a:t>Mostrar la terminal de la VM: uname -m → s390x y los dos contenedores corriendo. Todo corre en LinuxONE, en dos contenedores: el del hospital, con la llave, y el servicio de riesgo, sin ella; entre ellos, TLS 1.3 mutuo. En la demo comparten VM; en producción, el del hospital vive en sus instalaciones. La aritmética homomórfica son exponenciaciones con enteros de miles de bits: cómputo pesado, justo para IBM Z.</a:t>
             </a:r>
             <a:endParaRPr lang="en-US" dirty="0"/>
           </a:p>
@@ -986,7 +986,7 @@
           <a:p>
             <a:r>
               <a:rPr lang="en-US" dirty="0"/>
-              <a:t>Pantalla dividida. A la izquierda, lo que ve el servidor: solo números cifrados. A la derecha, lo que ve el hospital: el riesgo, los factores principales y la explicación de Granite. Abajo, medido en LinuxONE sobre [n] pacientes: el AUC en claro contra el cifrado [cifra real] y la latencia por paciente [cifra real].</a:t>
+              <a:t>Esta es la demo real. A la izquierda, lo que ve el servicio de riesgo: 21 números cifrados y el puntaje cifrado que devuelve. A la derecha, lo que ve el hospital: el riesgo, la decisión frente al umbral y los factores que más pesan. En 2,000 pacientes de prueba, los 2,000 resultados descifrados son idénticos a la referencia y el AUC es el mismo cifrado que en claro: 0.808. Cifras locales; en el video se muestran las de LinuxONE.</a:t>
             </a:r>
             <a:endParaRPr lang="en-US" dirty="0"/>
           </a:p>
@@ -1074,7 +1074,7 @@
           <a:p>
             <a:r>
               <a:rPr lang="en-US" dirty="0"/>
-              <a:t>Entrenamos con 253 mil registros públicos de los CDC. Los datos de pacientes solo llegan cifrados. (Es una prueba técnica con datos de EE. UU.; la evaluación externa exploratoria con ENSANUT está pendiente.)</a:t>
+              <a:t>Entrenamos con 253 mil registros públicos de los CDC: AUC 0.83 en prueba y 80% de sensibilidad con el umbral fijado en validación. Los datos de pacientes solo llegan cifrados. (Es una prueba técnica con datos de EE. UU.; la evaluación externa exploratoria con ENSANUT está pendiente.)</a:t>
             </a:r>
             <a:endParaRPr lang="en-US" dirty="0"/>
           </a:p>
@@ -4030,7 +4030,7 @@
                   <a:schemeClr val="bg2"/>
                 </a:solidFill>
               </a:rPr>
-              <a:t>El hospital ve el riesgo y Granite lo explica en lenguaje claro</a:t>
+              <a:t>El hospital ve el riesgo y los factores que más pesan</a:t>
             </a:r>
             <a:endParaRPr lang="en-US" sz="1200" dirty="0"/>
           </a:p>
@@ -6237,7 +6237,7 @@
                           <a:ea typeface="Arial" pitchFamily="34" charset="-122"/>
                           <a:cs typeface="Arial" pitchFamily="34" charset="-120"/>
                         </a:rPr>
-                        <a:t>Granite (entorno del hospital)</a:t>
+                        <a:t>Explicación (entorno del hospital)</a:t>
                       </a:r>
                       <a:endParaRPr lang="en-US" sz="1200" dirty="0">
                         <a:latin typeface="Arial" charset="0"/>
@@ -6302,7 +6302,7 @@
                           <a:ea typeface="Arial" pitchFamily="34" charset="-122"/>
                           <a:cs typeface="Arial" pitchFamily="34" charset="-120"/>
                         </a:rPr>
-                        <a:t>Solo lo que el hospital le pase</a:t>
+                        <a:t>Solo el hospital</a:t>
                       </a:r>
                       <a:endParaRPr lang="en-US" sz="1200" dirty="0">
                         <a:latin typeface="Arial" charset="0"/>
@@ -7153,7 +7153,7 @@
       </p:sp>
       <p:sp>
         <p:nvSpPr>
-          <p:cNvPr id="23" name="Granite · llama.cpp"/>
+          <p:cNvPr id="23" name="Explicación"/>
           <p:cNvSpPr/>
           <p:nvPr/>
         </p:nvSpPr>
@@ -7205,7 +7205,7 @@
                   <a:schemeClr val="bg1"/>
                 </a:solidFill>
               </a:rPr>
-              <a:t>Granite · llama.cpp</a:t>
+              <a:t>Explicación</a:t>
             </a:r>
             <a:endParaRPr lang="en-US" sz="1200" dirty="0"/>
           </a:p>
@@ -7241,7 +7241,7 @@
                   <a:schemeClr val="bg2"/>
                 </a:solidFill>
               </a:rPr>
-              <a:t>explica al paciente</a:t>
+              <a:t>factores que más pesan</a:t>
             </a:r>
             <a:endParaRPr lang="en-US" sz="1000" dirty="0"/>
           </a:p>
@@ -8026,7 +8026,7 @@
                   <a:schemeClr val="bg2"/>
                 </a:solidFill>
               </a:rPr>
-              <a:t>Muchos pacientes en paralelo en una sola plataforma; medido en vivo</a:t>
+              <a:t>Muchos pacientes en una sola plataforma; se mide en LinuxONE</a:t>
             </a:r>
             <a:endParaRPr lang="en-US" sz="1200" dirty="0"/>
           </a:p>
@@ -8073,7 +8073,7 @@
                   <a:schemeClr val="bg2"/>
                 </a:solidFill>
               </a:rPr>
-              <a:t>Python · scikit-learn · python-paillier · TenSEAL/OpenFHE (ruta CKKS) · Granite (llama.cpp) · OpenSSL · Docker · Jupyter Lab ML</a:t>
+              <a:t>Python · scikit-learn · python-paillier + gmpy2 · cryptography (TLS 1.3, AES-256-GCM) · Docker (Ubuntu 24.04, s390x)</a:t>
             </a:r>
             <a:endParaRPr lang="en-US" sz="1200" dirty="0"/>
           </a:p>
@@ -8181,7 +8181,7 @@
                   <a:schemeClr val="accent5"/>
                 </a:solidFill>
               </a:rPr>
-              <a:t>05 · DEMO EN VIVO</a:t>
+              <a:t>05 · DEMO REAL</a:t>
             </a:r>
             <a:endParaRPr lang="en-US" sz="1200" dirty="0"/>
           </a:p>
@@ -8219,64 +8219,15 @@
                   <a:schemeClr val="bg1"/>
                 </a:solidFill>
               </a:rPr>
-              <a:t>Pantalla dividida: el servidor no ve nada, el hospital ve todo</a:t>
+              <a:t>El servicio solo ve cifrados; el hospital ve el riesgo</a:t>
             </a:r>
             <a:endParaRPr lang="en-US" sz="3000" dirty="0"/>
           </a:p>
         </p:txBody>
-      </p:sp>
-      <p:sp>
-        <p:nvSpPr>
-          <p:cNvPr id="4" name="Vista servidor"/>
-          <p:cNvSpPr/>
-          <p:nvPr/>
-        </p:nvSpPr>
-        <p:spPr>
-          <a:xfrm>
-            <a:off x="548640" y="1783080"/>
-            <a:ext cx="5440680" cy="3383280"/>
-          </a:xfrm>
-          <a:prstGeom prst="roundRect">
-            <a:avLst>
-              <a:gd name="adj" fmla="val 2703"/>
-            </a:avLst>
-          </a:prstGeom>
-          <a:solidFill>
-            <a:schemeClr val="tx1"/>
-          </a:solidFill>
-          <a:ln w="9525">
-            <a:solidFill>
-              <a:schemeClr val="accent6">
-                <a:alpha val="70000"/>
-              </a:schemeClr>
-            </a:solidFill>
-            <a:prstDash val="solid"/>
-          </a:ln>
-        </p:spPr>
-      </p:sp>
-      <p:sp>
-        <p:nvSpPr>
-          <p:cNvPr id="5" name="Servidor círculo"/>
-          <p:cNvSpPr/>
-          <p:nvPr/>
-        </p:nvSpPr>
-        <p:spPr>
-          <a:xfrm>
-            <a:off x="731520" y="1938528"/>
-            <a:ext cx="384048" cy="384048"/>
-          </a:xfrm>
-          <a:prstGeom prst="ellipse">
-            <a:avLst/>
-          </a:prstGeom>
-          <a:solidFill>
-            <a:schemeClr val="tx2"/>
-          </a:solidFill>
-          <a:ln/>
-        </p:spPr>
       </p:sp>
       <p:pic>
         <p:nvPicPr>
-          <p:cNvPr id="6" name="Servidor ícono" descr="preencoded.png">    </p:cNvPr>
+          <p:cNvPr id="4" name="Captura real de la demo" descr="/private/tmp/claude-501/-Users-haowei-Documents-Antimarrulla/5372125f-ee1a-4aa0-8aef-43e32d332201/scratchpad/dx/demo_real.png">    </p:cNvPr>
           <p:cNvPicPr>
             <a:picLocks noChangeAspect="1"/>
           </p:cNvPicPr>
@@ -8290,8 +8241,8 @@
         </p:blipFill>
         <p:spPr>
           <a:xfrm>
-            <a:off x="816011" y="2023019"/>
-            <a:ext cx="215067" cy="215067"/>
+            <a:off x="548640" y="1691640"/>
+            <a:ext cx="5925312" cy="4114800"/>
           </a:xfrm>
           <a:prstGeom prst="rect">
             <a:avLst/>
@@ -8300,410 +8251,87 @@
       </p:pic>
       <p:sp>
         <p:nvSpPr>
-          <p:cNvPr id="7" name="Text 4"/>
+          <p:cNvPr id="5" name="Text 2"/>
           <p:cNvSpPr txBox="1"/>
           <p:nvPr/>
         </p:nvSpPr>
         <p:spPr>
           <a:xfrm>
-            <a:off x="1234440" y="1938528"/>
-            <a:ext cx="4114800" cy="384048"/>
-          </a:xfrm>
-          <a:prstGeom prst="rect">
-            <a:avLst/>
-          </a:prstGeom>
-          <a:noFill/>
-          <a:ln/>
-        </p:spPr>
-        <p:txBody>
-          <a:bodyPr wrap="square" lIns="0" tIns="0" rIns="0" bIns="0" rtlCol="0" anchor="ctr"/>
-          <a:lstStyle/>
-          <a:p>
-            <a:pPr indent="0" marL="0">
-              <a:buNone/>
-            </a:pPr>
-            <a:r>
-              <a:rPr lang="en-US" sz="1200" b="1" spc="100" kern="0" dirty="0">
+            <a:off x="548640" y="5852160"/>
+            <a:ext cx="5925312" cy="256032"/>
+          </a:xfrm>
+          <a:prstGeom prst="rect">
+            <a:avLst/>
+          </a:prstGeom>
+          <a:noFill/>
+          <a:ln/>
+        </p:spPr>
+        <p:txBody>
+          <a:bodyPr wrap="square" lIns="0" tIns="0" rIns="0" bIns="0" rtlCol="0" anchor="t"/>
+          <a:lstStyle/>
+          <a:p>
+            <a:pPr indent="0" marL="0">
+              <a:buNone/>
+            </a:pPr>
+            <a:r>
+              <a:rPr lang="en-US" sz="1000" dirty="0">
                 <a:solidFill>
                   <a:schemeClr val="accent6"/>
                 </a:solidFill>
               </a:rPr>
-              <a:t>LO QUE VE EL SERVIDOR</a:t>
-            </a:r>
-            <a:endParaRPr lang="en-US" sz="1200" dirty="0"/>
-          </a:p>
-        </p:txBody>
-      </p:sp>
-      <p:sp>
-        <p:nvSpPr>
-          <p:cNvPr id="8" name="Text 5"/>
-          <p:cNvSpPr txBox="1"/>
-          <p:nvPr/>
-        </p:nvSpPr>
-        <p:spPr>
-          <a:xfrm>
-            <a:off x="777240" y="2487168"/>
-            <a:ext cx="5029200" cy="347472"/>
-          </a:xfrm>
-          <a:prstGeom prst="rect">
-            <a:avLst/>
-          </a:prstGeom>
-          <a:noFill/>
-          <a:ln/>
-        </p:spPr>
-        <p:txBody>
-          <a:bodyPr wrap="square" lIns="0" tIns="0" rIns="0" bIns="0" rtlCol="0" anchor="ctr"/>
-          <a:lstStyle/>
-          <a:p>
-            <a:pPr indent="0" marL="0">
-              <a:buNone/>
-            </a:pPr>
-            <a:r>
-              <a:rPr lang="en-US" sz="1400" dirty="0">
-                <a:solidFill>
-                  <a:schemeClr val="accent6"/>
-                </a:solidFill>
-                <a:latin typeface="Courier New" pitchFamily="34" charset="0"/>
-                <a:ea typeface="Courier New" pitchFamily="34" charset="-122"/>
-                <a:cs typeface="Courier New" pitchFamily="34" charset="-120"/>
-              </a:rPr>
-              <a:t>Age          </a:t>
-            </a:r>
-            <a:pPr indent="0" marL="0">
-              <a:buNone/>
-            </a:pPr>
-            <a:r>
-              <a:rPr lang="en-US" sz="1400" dirty="0">
-                <a:solidFill>
-                  <a:schemeClr val="accent5"/>
-                </a:solidFill>
-                <a:latin typeface="Courier New" pitchFamily="34" charset="0"/>
-                <a:ea typeface="Courier New" pitchFamily="34" charset="-122"/>
-                <a:cs typeface="Courier New" pitchFamily="34" charset="-120"/>
-              </a:rPr>
-              <a:t>8f3a91c4e70b5d2a…b21d</a:t>
-            </a:r>
-            <a:endParaRPr lang="en-US" sz="1400" dirty="0"/>
-          </a:p>
-        </p:txBody>
-      </p:sp>
-      <p:sp>
-        <p:nvSpPr>
-          <p:cNvPr id="9" name="Text 6"/>
-          <p:cNvSpPr txBox="1"/>
-          <p:nvPr/>
-        </p:nvSpPr>
-        <p:spPr>
-          <a:xfrm>
-            <a:off x="777240" y="2889504"/>
-            <a:ext cx="5029200" cy="347472"/>
-          </a:xfrm>
-          <a:prstGeom prst="rect">
-            <a:avLst/>
-          </a:prstGeom>
-          <a:noFill/>
-          <a:ln/>
-        </p:spPr>
-        <p:txBody>
-          <a:bodyPr wrap="square" lIns="0" tIns="0" rIns="0" bIns="0" rtlCol="0" anchor="ctr"/>
-          <a:lstStyle/>
-          <a:p>
-            <a:pPr indent="0" marL="0">
-              <a:buNone/>
-            </a:pPr>
-            <a:r>
-              <a:rPr lang="en-US" sz="1400" dirty="0">
-                <a:solidFill>
-                  <a:schemeClr val="accent6"/>
-                </a:solidFill>
-                <a:latin typeface="Courier New" pitchFamily="34" charset="0"/>
-                <a:ea typeface="Courier New" pitchFamily="34" charset="-122"/>
-                <a:cs typeface="Courier New" pitchFamily="34" charset="-120"/>
-              </a:rPr>
-              <a:t>BMI          </a:t>
-            </a:r>
-            <a:pPr indent="0" marL="0">
-              <a:buNone/>
-            </a:pPr>
-            <a:r>
-              <a:rPr lang="en-US" sz="1400" dirty="0">
-                <a:solidFill>
-                  <a:schemeClr val="accent5"/>
-                </a:solidFill>
-                <a:latin typeface="Courier New" pitchFamily="34" charset="0"/>
-                <a:ea typeface="Courier New" pitchFamily="34" charset="-122"/>
-                <a:cs typeface="Courier New" pitchFamily="34" charset="-120"/>
-              </a:rPr>
-              <a:t>c09e44a1f7d3826b…7e4a</a:t>
-            </a:r>
-            <a:endParaRPr lang="en-US" sz="1400" dirty="0"/>
-          </a:p>
-        </p:txBody>
-      </p:sp>
-      <p:sp>
-        <p:nvSpPr>
-          <p:cNvPr id="10" name="Text 7"/>
-          <p:cNvSpPr txBox="1"/>
-          <p:nvPr/>
-        </p:nvSpPr>
-        <p:spPr>
-          <a:xfrm>
-            <a:off x="777240" y="3291840"/>
-            <a:ext cx="5029200" cy="347472"/>
-          </a:xfrm>
-          <a:prstGeom prst="rect">
-            <a:avLst/>
-          </a:prstGeom>
-          <a:noFill/>
-          <a:ln/>
-        </p:spPr>
-        <p:txBody>
-          <a:bodyPr wrap="square" lIns="0" tIns="0" rIns="0" bIns="0" rtlCol="0" anchor="ctr"/>
-          <a:lstStyle/>
-          <a:p>
-            <a:pPr indent="0" marL="0">
-              <a:buNone/>
-            </a:pPr>
-            <a:r>
-              <a:rPr lang="en-US" sz="1400" dirty="0">
-                <a:solidFill>
-                  <a:schemeClr val="accent6"/>
-                </a:solidFill>
-                <a:latin typeface="Courier New" pitchFamily="34" charset="0"/>
-                <a:ea typeface="Courier New" pitchFamily="34" charset="-122"/>
-                <a:cs typeface="Courier New" pitchFamily="34" charset="-120"/>
-              </a:rPr>
-              <a:t>HighBP       </a:t>
-            </a:r>
-            <a:pPr indent="0" marL="0">
-              <a:buNone/>
-            </a:pPr>
-            <a:r>
-              <a:rPr lang="en-US" sz="1400" dirty="0">
-                <a:solidFill>
-                  <a:schemeClr val="accent5"/>
-                </a:solidFill>
-                <a:latin typeface="Courier New" pitchFamily="34" charset="0"/>
-                <a:ea typeface="Courier New" pitchFamily="34" charset="-122"/>
-                <a:cs typeface="Courier New" pitchFamily="34" charset="-120"/>
-              </a:rPr>
-              <a:t>5b7d02e9c1a4f863…09c3</a:t>
-            </a:r>
-            <a:endParaRPr lang="en-US" sz="1400" dirty="0"/>
-          </a:p>
-        </p:txBody>
-      </p:sp>
-      <p:sp>
-        <p:nvSpPr>
-          <p:cNvPr id="11" name="Text 8"/>
-          <p:cNvSpPr txBox="1"/>
-          <p:nvPr/>
-        </p:nvSpPr>
-        <p:spPr>
-          <a:xfrm>
-            <a:off x="777240" y="3694176"/>
-            <a:ext cx="5029200" cy="347472"/>
-          </a:xfrm>
-          <a:prstGeom prst="rect">
-            <a:avLst/>
-          </a:prstGeom>
-          <a:noFill/>
-          <a:ln/>
-        </p:spPr>
-        <p:txBody>
-          <a:bodyPr wrap="square" lIns="0" tIns="0" rIns="0" bIns="0" rtlCol="0" anchor="ctr"/>
-          <a:lstStyle/>
-          <a:p>
-            <a:pPr indent="0" marL="0">
-              <a:buNone/>
-            </a:pPr>
-            <a:r>
-              <a:rPr lang="en-US" sz="1400" dirty="0">
-                <a:solidFill>
-                  <a:schemeClr val="accent6"/>
-                </a:solidFill>
-                <a:latin typeface="Courier New" pitchFamily="34" charset="0"/>
-                <a:ea typeface="Courier New" pitchFamily="34" charset="-122"/>
-                <a:cs typeface="Courier New" pitchFamily="34" charset="-120"/>
-              </a:rPr>
-              <a:t>HighChol     </a:t>
-            </a:r>
-            <a:pPr indent="0" marL="0">
-              <a:buNone/>
-            </a:pPr>
-            <a:r>
-              <a:rPr lang="en-US" sz="1400" dirty="0">
-                <a:solidFill>
-                  <a:schemeClr val="accent5"/>
-                </a:solidFill>
-                <a:latin typeface="Courier New" pitchFamily="34" charset="0"/>
-                <a:ea typeface="Courier New" pitchFamily="34" charset="-122"/>
-                <a:cs typeface="Courier New" pitchFamily="34" charset="-120"/>
-              </a:rPr>
-              <a:t>e1a6f3b8902dc475…d8f1</a:t>
-            </a:r>
-            <a:endParaRPr lang="en-US" sz="1400" dirty="0"/>
-          </a:p>
-        </p:txBody>
-      </p:sp>
-      <p:sp>
-        <p:nvSpPr>
-          <p:cNvPr id="12" name="Text 9"/>
-          <p:cNvSpPr txBox="1"/>
-          <p:nvPr/>
-        </p:nvSpPr>
-        <p:spPr>
-          <a:xfrm>
-            <a:off x="777240" y="4096512"/>
-            <a:ext cx="5029200" cy="347472"/>
-          </a:xfrm>
-          <a:prstGeom prst="rect">
-            <a:avLst/>
-          </a:prstGeom>
-          <a:noFill/>
-          <a:ln/>
-        </p:spPr>
-        <p:txBody>
-          <a:bodyPr wrap="square" lIns="0" tIns="0" rIns="0" bIns="0" rtlCol="0" anchor="ctr"/>
-          <a:lstStyle/>
-          <a:p>
-            <a:pPr indent="0" marL="0">
-              <a:buNone/>
-            </a:pPr>
-            <a:r>
-              <a:rPr lang="en-US" sz="1400" dirty="0">
-                <a:solidFill>
-                  <a:schemeClr val="accent6"/>
-                </a:solidFill>
-                <a:latin typeface="Courier New" pitchFamily="34" charset="0"/>
-                <a:ea typeface="Courier New" pitchFamily="34" charset="-122"/>
-                <a:cs typeface="Courier New" pitchFamily="34" charset="-120"/>
-              </a:rPr>
-              <a:t>PhysActivity </a:t>
-            </a:r>
-            <a:pPr indent="0" marL="0">
-              <a:buNone/>
-            </a:pPr>
-            <a:r>
-              <a:rPr lang="en-US" sz="1400" dirty="0">
-                <a:solidFill>
-                  <a:schemeClr val="accent5"/>
-                </a:solidFill>
-                <a:latin typeface="Courier New" pitchFamily="34" charset="0"/>
-                <a:ea typeface="Courier New" pitchFamily="34" charset="-122"/>
-                <a:cs typeface="Courier New" pitchFamily="34" charset="-120"/>
-              </a:rPr>
-              <a:t>37c9b0e45a1f6d28…a65e</a:t>
-            </a:r>
-            <a:endParaRPr lang="en-US" sz="1400" dirty="0"/>
-          </a:p>
-        </p:txBody>
-      </p:sp>
-      <p:sp>
-        <p:nvSpPr>
-          <p:cNvPr id="13" name="Text 10"/>
-          <p:cNvSpPr txBox="1"/>
-          <p:nvPr/>
-        </p:nvSpPr>
-        <p:spPr>
-          <a:xfrm>
-            <a:off x="777240" y="4498848"/>
-            <a:ext cx="5029200" cy="347472"/>
-          </a:xfrm>
-          <a:prstGeom prst="rect">
-            <a:avLst/>
-          </a:prstGeom>
-          <a:noFill/>
-          <a:ln/>
-        </p:spPr>
-        <p:txBody>
-          <a:bodyPr wrap="square" lIns="0" tIns="0" rIns="0" bIns="0" rtlCol="0" anchor="ctr"/>
-          <a:lstStyle/>
-          <a:p>
-            <a:pPr indent="0" marL="0">
-              <a:buNone/>
-            </a:pPr>
-            <a:r>
-              <a:rPr lang="en-US" sz="1400" dirty="0">
-                <a:solidFill>
-                  <a:schemeClr val="accent6"/>
-                </a:solidFill>
-                <a:latin typeface="Courier New" pitchFamily="34" charset="0"/>
-                <a:ea typeface="Courier New" pitchFamily="34" charset="-122"/>
-                <a:cs typeface="Courier New" pitchFamily="34" charset="-120"/>
-              </a:rPr>
-              <a:t>Enc(logit)   </a:t>
-            </a:r>
-            <a:pPr indent="0" marL="0">
-              <a:buNone/>
-            </a:pPr>
-            <a:r>
-              <a:rPr lang="en-US" sz="1400" dirty="0">
-                <a:solidFill>
-                  <a:schemeClr val="accent5"/>
-                </a:solidFill>
-                <a:latin typeface="Courier New" pitchFamily="34" charset="0"/>
-                <a:ea typeface="Courier New" pitchFamily="34" charset="-122"/>
-                <a:cs typeface="Courier New" pitchFamily="34" charset="-120"/>
-              </a:rPr>
-              <a:t>a4d2e7091f3cb658…3f07</a:t>
-            </a:r>
-            <a:endParaRPr lang="en-US" sz="1400" dirty="0"/>
-          </a:p>
-        </p:txBody>
-      </p:sp>
-      <p:sp>
-        <p:nvSpPr>
-          <p:cNvPr id="14" name="Vista hospital"/>
+              <a:t>Captura real de la UI con un paciente sintético (contenedores locales, 17 oct)</a:t>
+            </a:r>
+            <a:endParaRPr lang="en-US" sz="1000" dirty="0"/>
+          </a:p>
+        </p:txBody>
+      </p:sp>
+      <p:sp>
+        <p:nvSpPr>
+          <p:cNvPr id="6" name="2,000 de 2,000"/>
           <p:cNvSpPr/>
           <p:nvPr/>
         </p:nvSpPr>
         <p:spPr>
           <a:xfrm>
-            <a:off x="6199632" y="1783080"/>
-            <a:ext cx="5440680" cy="3383280"/>
+            <a:off x="6720840" y="1691640"/>
+            <a:ext cx="4919472" cy="877824"/>
           </a:xfrm>
           <a:prstGeom prst="roundRect">
             <a:avLst>
-              <a:gd name="adj" fmla="val 2703"/>
+              <a:gd name="adj" fmla="val 10417"/>
             </a:avLst>
           </a:prstGeom>
           <a:solidFill>
-            <a:schemeClr val="tx2"/>
+            <a:schemeClr val="accent1">
+              <a:alpha val="15000"/>
+            </a:schemeClr>
           </a:solidFill>
-          <a:ln w="9525">
-            <a:solidFill>
-              <a:schemeClr val="accent2">
-                <a:alpha val="70000"/>
-              </a:schemeClr>
-            </a:solidFill>
-            <a:prstDash val="solid"/>
-          </a:ln>
-        </p:spPr>
-      </p:sp>
-      <p:sp>
-        <p:nvSpPr>
-          <p:cNvPr id="15" name="Hospital círculo"/>
+          <a:ln/>
+        </p:spPr>
+      </p:sp>
+      <p:sp>
+        <p:nvSpPr>
+          <p:cNvPr id="7" name="2,000 de 2,000 círculo"/>
           <p:cNvSpPr/>
           <p:nvPr/>
         </p:nvSpPr>
         <p:spPr>
           <a:xfrm>
-            <a:off x="6382512" y="1938528"/>
-            <a:ext cx="384048" cy="384048"/>
+            <a:off x="6858000" y="1874520"/>
+            <a:ext cx="512064" cy="512064"/>
           </a:xfrm>
           <a:prstGeom prst="ellipse">
             <a:avLst/>
           </a:prstGeom>
           <a:solidFill>
-            <a:schemeClr val="accent2"/>
+            <a:schemeClr val="accent1"/>
           </a:solidFill>
           <a:ln/>
         </p:spPr>
       </p:sp>
       <p:pic>
         <p:nvPicPr>
-          <p:cNvPr id="16" name="Hospital ícono" descr="preencoded.png">    </p:cNvPr>
+          <p:cNvPr id="8" name="2,000 de 2,000 ícono" descr="preencoded.png">    </p:cNvPr>
           <p:cNvPicPr>
             <a:picLocks noChangeAspect="1"/>
           </p:cNvPicPr>
@@ -8717,8 +8345,8 @@
         </p:blipFill>
         <p:spPr>
           <a:xfrm>
-            <a:off x="6467003" y="2023019"/>
-            <a:ext cx="215067" cy="215067"/>
+            <a:off x="6970654" y="1987174"/>
+            <a:ext cx="286756" cy="286756"/>
           </a:xfrm>
           <a:prstGeom prst="rect">
             <a:avLst/>
@@ -8727,14 +8355,14 @@
       </p:pic>
       <p:sp>
         <p:nvSpPr>
-          <p:cNvPr id="17" name="Text 13"/>
+          <p:cNvPr id="9" name="Text 5"/>
           <p:cNvSpPr txBox="1"/>
           <p:nvPr/>
         </p:nvSpPr>
         <p:spPr>
           <a:xfrm>
-            <a:off x="6885432" y="1938528"/>
-            <a:ext cx="4114800" cy="384048"/>
+            <a:off x="7498080" y="1746504"/>
+            <a:ext cx="4023360" cy="365760"/>
           </a:xfrm>
           <a:prstGeom prst="rect">
             <a:avLst/>
@@ -8750,237 +8378,87 @@
               <a:buNone/>
             </a:pPr>
             <a:r>
-              <a:rPr lang="en-US" sz="1200" b="1" spc="100" kern="0" dirty="0">
-                <a:solidFill>
-                  <a:schemeClr val="accent2"/>
-                </a:solidFill>
-              </a:rPr>
-              <a:t>LO QUE VE EL HOSPITAL</a:t>
-            </a:r>
-            <a:endParaRPr lang="en-US" sz="1200" dirty="0"/>
-          </a:p>
-        </p:txBody>
-      </p:sp>
-      <p:sp>
-        <p:nvSpPr>
-          <p:cNvPr id="18" name="Text 14"/>
+              <a:rPr lang="en-US" sz="1700" b="1" dirty="0">
+                <a:solidFill>
+                  <a:schemeClr val="bg1"/>
+                </a:solidFill>
+              </a:rPr>
+              <a:t>2,000 de 2,000</a:t>
+            </a:r>
+            <a:endParaRPr lang="en-US" sz="1700" dirty="0"/>
+          </a:p>
+        </p:txBody>
+      </p:sp>
+      <p:sp>
+        <p:nvSpPr>
+          <p:cNvPr id="10" name="Text 6"/>
           <p:cNvSpPr txBox="1"/>
           <p:nvPr/>
         </p:nvSpPr>
         <p:spPr>
           <a:xfrm>
-            <a:off x="6400800" y="2468880"/>
-            <a:ext cx="2743200" cy="320040"/>
-          </a:xfrm>
-          <a:prstGeom prst="rect">
-            <a:avLst/>
-          </a:prstGeom>
-          <a:noFill/>
-          <a:ln/>
-        </p:spPr>
-        <p:txBody>
-          <a:bodyPr wrap="square" lIns="0" tIns="0" rIns="0" bIns="0" rtlCol="0" anchor="ctr"/>
-          <a:lstStyle/>
-          <a:p>
-            <a:pPr indent="0" marL="0">
-              <a:buNone/>
-            </a:pPr>
-            <a:r>
-              <a:rPr lang="en-US" sz="1400" dirty="0">
+            <a:off x="7498080" y="2112264"/>
+            <a:ext cx="4023360" cy="402336"/>
+          </a:xfrm>
+          <a:prstGeom prst="rect">
+            <a:avLst/>
+          </a:prstGeom>
+          <a:noFill/>
+          <a:ln/>
+        </p:spPr>
+        <p:txBody>
+          <a:bodyPr wrap="square" lIns="0" tIns="0" rIns="0" bIns="0" rtlCol="0" anchor="t"/>
+          <a:lstStyle/>
+          <a:p>
+            <a:pPr indent="0" marL="0">
+              <a:buNone/>
+            </a:pPr>
+            <a:r>
+              <a:rPr lang="en-US" sz="1100" dirty="0">
                 <a:solidFill>
                   <a:schemeClr val="bg2"/>
                 </a:solidFill>
               </a:rPr>
-              <a:t>Paciente 0427</a:t>
-            </a:r>
-            <a:endParaRPr lang="en-US" sz="1400" dirty="0"/>
-          </a:p>
-        </p:txBody>
-      </p:sp>
-      <p:sp>
-        <p:nvSpPr>
-          <p:cNvPr id="19" name="Riesgo"/>
+              <a:t>enteros descifrados idénticos a la referencia (error cero)</a:t>
+            </a:r>
+            <a:endParaRPr lang="en-US" sz="1100" dirty="0"/>
+          </a:p>
+        </p:txBody>
+      </p:sp>
+      <p:sp>
+        <p:nvSpPr>
+          <p:cNvPr id="11" name="ROC-AUC 0.808"/>
           <p:cNvSpPr/>
           <p:nvPr/>
         </p:nvSpPr>
         <p:spPr>
           <a:xfrm>
-            <a:off x="6400800" y="2834640"/>
-            <a:ext cx="2194560" cy="960120"/>
+            <a:off x="6720840" y="2697480"/>
+            <a:ext cx="4919472" cy="877824"/>
           </a:xfrm>
           <a:prstGeom prst="roundRect">
             <a:avLst>
-              <a:gd name="adj" fmla="val 9524"/>
+              <a:gd name="adj" fmla="val 10417"/>
             </a:avLst>
           </a:prstGeom>
           <a:solidFill>
-            <a:schemeClr val="accent4">
-              <a:alpha val="20000"/>
+            <a:schemeClr val="accent1">
+              <a:alpha val="15000"/>
             </a:schemeClr>
           </a:solidFill>
-          <a:ln w="9525">
-            <a:solidFill>
-              <a:schemeClr val="accent4">
-                <a:alpha val="80000"/>
-              </a:schemeClr>
-            </a:solidFill>
-            <a:prstDash val="solid"/>
-          </a:ln>
-        </p:spPr>
-      </p:sp>
-      <p:sp>
-        <p:nvSpPr>
-          <p:cNvPr id="20" name="Text 16"/>
-          <p:cNvSpPr txBox="1"/>
-          <p:nvPr/>
-        </p:nvSpPr>
-        <p:spPr>
-          <a:xfrm>
-            <a:off x="6537960" y="2862072"/>
-            <a:ext cx="1920240" cy="914400"/>
-          </a:xfrm>
-          <a:prstGeom prst="rect">
-            <a:avLst/>
-          </a:prstGeom>
-          <a:noFill/>
-          <a:ln/>
-        </p:spPr>
-        <p:txBody>
-          <a:bodyPr wrap="square" lIns="0" tIns="0" rIns="0" bIns="0" rtlCol="0" anchor="ctr"/>
-          <a:lstStyle/>
-          <a:p>
-            <a:pPr indent="0" marL="0">
-              <a:buNone/>
-            </a:pPr>
-            <a:r>
-              <a:rPr lang="en-US" sz="1100" b="1" spc="100" kern="0" dirty="0">
-                <a:solidFill>
-                  <a:schemeClr val="accent4"/>
-                </a:solidFill>
-              </a:rPr>
-              <a:t>RIESGO</a:t>
-            </a:r>
-            <a:endParaRPr lang="en-US" sz="1400" dirty="0"/>
-          </a:p>
-          <a:p>
-            <a:pPr indent="0" marL="0">
-              <a:buNone/>
-            </a:pPr>
-            <a:r>
-              <a:rPr lang="en-US" sz="3000" b="1" dirty="0">
-                <a:solidFill>
-                  <a:schemeClr val="bg1"/>
-                </a:solidFill>
-              </a:rPr>
-              <a:t>ALTO</a:t>
-            </a:r>
-            <a:endParaRPr lang="en-US" sz="1400" dirty="0"/>
-          </a:p>
-        </p:txBody>
-      </p:sp>
-      <p:sp>
-        <p:nvSpPr>
-          <p:cNvPr id="21" name="Text 17"/>
-          <p:cNvSpPr txBox="1"/>
-          <p:nvPr/>
-        </p:nvSpPr>
-        <p:spPr>
-          <a:xfrm>
-            <a:off x="8823960" y="2834640"/>
-            <a:ext cx="2651760" cy="1005840"/>
-          </a:xfrm>
-          <a:prstGeom prst="rect">
-            <a:avLst/>
-          </a:prstGeom>
-          <a:noFill/>
-          <a:ln/>
-        </p:spPr>
-        <p:txBody>
-          <a:bodyPr wrap="square" lIns="0" tIns="0" rIns="0" bIns="0" rtlCol="0" anchor="t"/>
-          <a:lstStyle/>
-          <a:p>
-            <a:pPr indent="0" marL="0">
-              <a:spcAft>
-                <a:spcPts val="200"/>
-              </a:spcAft>
-              <a:buNone/>
-            </a:pPr>
-            <a:r>
-              <a:rPr lang="en-US" sz="1200" b="1" dirty="0">
-                <a:solidFill>
-                  <a:schemeClr val="bg1"/>
-                </a:solidFill>
-              </a:rPr>
-              <a:t>Factores principales</a:t>
-            </a:r>
-            <a:endParaRPr lang="en-US" sz="1200" dirty="0"/>
-          </a:p>
-          <a:p>
-            <a:pPr marL="342900" indent="-342900">
-              <a:spcAft>
-                <a:spcPts val="200"/>
-              </a:spcAft>
-              <a:buSzPct val="100000"/>
-              <a:buChar char="•"/>
-            </a:pPr>
-            <a:r>
-              <a:rPr lang="en-US" sz="1200" dirty="0">
-                <a:solidFill>
-                  <a:schemeClr val="bg2"/>
-                </a:solidFill>
-              </a:rPr>
-              <a:t>IMC elevado</a:t>
-            </a:r>
-            <a:endParaRPr lang="en-US" sz="1200" dirty="0"/>
-          </a:p>
-          <a:p>
-            <a:pPr marL="342900" indent="-342900">
-              <a:spcAft>
-                <a:spcPts val="200"/>
-              </a:spcAft>
-              <a:buSzPct val="100000"/>
-              <a:buChar char="•"/>
-            </a:pPr>
-            <a:r>
-              <a:rPr lang="en-US" sz="1200" dirty="0">
-                <a:solidFill>
-                  <a:schemeClr val="bg2"/>
-                </a:solidFill>
-              </a:rPr>
-              <a:t>Presión alta</a:t>
-            </a:r>
-            <a:endParaRPr lang="en-US" sz="1200" dirty="0"/>
-          </a:p>
-          <a:p>
-            <a:pPr marL="342900" indent="-342900">
-              <a:spcAft>
-                <a:spcPts val="200"/>
-              </a:spcAft>
-              <a:buSzPct val="100000"/>
-              <a:buChar char="•"/>
-            </a:pPr>
-            <a:r>
-              <a:rPr lang="en-US" sz="1200" dirty="0">
-                <a:solidFill>
-                  <a:schemeClr val="bg2"/>
-                </a:solidFill>
-              </a:rPr>
-              <a:t>Sin actividad física</a:t>
-            </a:r>
-            <a:endParaRPr lang="en-US" sz="1200" dirty="0"/>
-          </a:p>
-        </p:txBody>
-      </p:sp>
-      <p:sp>
-        <p:nvSpPr>
-          <p:cNvPr id="22" name="Granite círculo"/>
+          <a:ln/>
+        </p:spPr>
+      </p:sp>
+      <p:sp>
+        <p:nvSpPr>
+          <p:cNvPr id="12" name="ROC-AUC 0.808 círculo"/>
           <p:cNvSpPr/>
           <p:nvPr/>
         </p:nvSpPr>
         <p:spPr>
           <a:xfrm>
-            <a:off x="6400800" y="4041648"/>
-            <a:ext cx="384048" cy="384048"/>
+            <a:off x="6858000" y="2880360"/>
+            <a:ext cx="512064" cy="512064"/>
           </a:xfrm>
           <a:prstGeom prst="ellipse">
             <a:avLst/>
@@ -8993,7 +8471,7 @@
       </p:sp>
       <p:pic>
         <p:nvPicPr>
-          <p:cNvPr id="23" name="Granite ícono" descr="preencoded.png">    </p:cNvPr>
+          <p:cNvPr id="13" name="ROC-AUC 0.808 ícono" descr="preencoded.png">    </p:cNvPr>
           <p:cNvPicPr>
             <a:picLocks noChangeAspect="1"/>
           </p:cNvPicPr>
@@ -9007,8 +8485,8 @@
         </p:blipFill>
         <p:spPr>
           <a:xfrm>
-            <a:off x="6485291" y="4126139"/>
-            <a:ext cx="215067" cy="215067"/>
+            <a:off x="6970654" y="2993014"/>
+            <a:ext cx="286756" cy="286756"/>
           </a:xfrm>
           <a:prstGeom prst="rect">
             <a:avLst/>
@@ -9017,14 +8495,14 @@
       </p:pic>
       <p:sp>
         <p:nvSpPr>
-          <p:cNvPr id="24" name="Text 19"/>
+          <p:cNvPr id="14" name="Text 9"/>
           <p:cNvSpPr txBox="1"/>
           <p:nvPr/>
         </p:nvSpPr>
         <p:spPr>
           <a:xfrm>
-            <a:off x="6903720" y="3950208"/>
-            <a:ext cx="4572000" cy="868680"/>
+            <a:off x="7498080" y="2752344"/>
+            <a:ext cx="4023360" cy="365760"/>
           </a:xfrm>
           <a:prstGeom prst="rect">
             <a:avLst/>
@@ -9040,27 +8518,27 @@
               <a:buNone/>
             </a:pPr>
             <a:r>
-              <a:rPr lang="en-US" sz="1200" i="1" dirty="0">
+              <a:rPr lang="en-US" sz="1700" b="1" dirty="0">
                 <a:solidFill>
                   <a:schemeClr val="bg1"/>
                 </a:solidFill>
               </a:rPr>
-              <a:t>«Tu riesgo es alto, sobre todo por el peso y la presión. Te recomendamos una prueba de glucosa esta semana.» · Granite</a:t>
-            </a:r>
-            <a:endParaRPr lang="en-US" sz="1200" dirty="0"/>
-          </a:p>
-        </p:txBody>
-      </p:sp>
-      <p:sp>
-        <p:nvSpPr>
-          <p:cNvPr id="25" name="Text 20"/>
+              <a:t>ROC-AUC 0.808</a:t>
+            </a:r>
+            <a:endParaRPr lang="en-US" sz="1700" dirty="0"/>
+          </a:p>
+        </p:txBody>
+      </p:sp>
+      <p:sp>
+        <p:nvSpPr>
+          <p:cNvPr id="15" name="Text 10"/>
           <p:cNvSpPr txBox="1"/>
           <p:nvPr/>
         </p:nvSpPr>
         <p:spPr>
           <a:xfrm>
-            <a:off x="548640" y="5212080"/>
-            <a:ext cx="5486400" cy="228600"/>
+            <a:off x="7498080" y="3118104"/>
+            <a:ext cx="4023360" cy="402336"/>
           </a:xfrm>
           <a:prstGeom prst="rect">
             <a:avLst/>
@@ -9076,36 +8554,36 @@
               <a:buNone/>
             </a:pPr>
             <a:r>
-              <a:rPr lang="en-US" sz="1000" dirty="0">
-                <a:solidFill>
-                  <a:schemeClr val="accent6"/>
-                </a:solidFill>
-              </a:rPr>
-              <a:t>Maqueta ilustrativa de la demo</a:t>
-            </a:r>
-            <a:endParaRPr lang="en-US" sz="1000" dirty="0"/>
-          </a:p>
-        </p:txBody>
-      </p:sp>
-      <p:sp>
-        <p:nvSpPr>
-          <p:cNvPr id="26" name="AUC claro vs. cifrado"/>
+              <a:rPr lang="en-US" sz="1100" dirty="0">
+                <a:solidFill>
+                  <a:schemeClr val="bg2"/>
+                </a:solidFill>
+              </a:rPr>
+              <a:t>igual en flotante, punto fijo y cifrado sobre los mismos 2,000 pacientes</a:t>
+            </a:r>
+            <a:endParaRPr lang="en-US" sz="1100" dirty="0"/>
+          </a:p>
+        </p:txBody>
+      </p:sp>
+      <p:sp>
+        <p:nvSpPr>
+          <p:cNvPr id="16" name="128 ms (p50)"/>
           <p:cNvSpPr/>
           <p:nvPr/>
         </p:nvSpPr>
         <p:spPr>
           <a:xfrm>
-            <a:off x="548640" y="5486400"/>
-            <a:ext cx="2642616" cy="658368"/>
+            <a:off x="6720840" y="3703320"/>
+            <a:ext cx="4919472" cy="877824"/>
           </a:xfrm>
           <a:prstGeom prst="roundRect">
             <a:avLst>
-              <a:gd name="adj" fmla="val 13889"/>
+              <a:gd name="adj" fmla="val 10417"/>
             </a:avLst>
           </a:prstGeom>
           <a:solidFill>
             <a:schemeClr val="accent1">
-              <a:alpha val="20000"/>
+              <a:alpha val="15000"/>
             </a:schemeClr>
           </a:solidFill>
           <a:ln/>
@@ -9113,14 +8591,14 @@
       </p:sp>
       <p:sp>
         <p:nvSpPr>
-          <p:cNvPr id="27" name="AUC claro vs. cifrado círculo"/>
+          <p:cNvPr id="17" name="128 ms (p50) círculo"/>
           <p:cNvSpPr/>
           <p:nvPr/>
         </p:nvSpPr>
         <p:spPr>
           <a:xfrm>
-            <a:off x="685800" y="5586984"/>
-            <a:ext cx="457200" cy="457200"/>
+            <a:off x="6858000" y="3886200"/>
+            <a:ext cx="512064" cy="512064"/>
           </a:xfrm>
           <a:prstGeom prst="ellipse">
             <a:avLst/>
@@ -9133,7 +8611,7 @@
       </p:sp>
       <p:pic>
         <p:nvPicPr>
-          <p:cNvPr id="28" name="AUC claro vs. cifrado ícono" descr="preencoded.png">    </p:cNvPr>
+          <p:cNvPr id="18" name="128 ms (p50) ícono" descr="preencoded.png">    </p:cNvPr>
           <p:cNvPicPr>
             <a:picLocks noChangeAspect="1"/>
           </p:cNvPicPr>
@@ -9147,8 +8625,8 @@
         </p:blipFill>
         <p:spPr>
           <a:xfrm>
-            <a:off x="786384" y="5687568"/>
-            <a:ext cx="256032" cy="256032"/>
+            <a:off x="6970654" y="3998854"/>
+            <a:ext cx="286756" cy="286756"/>
           </a:xfrm>
           <a:prstGeom prst="rect">
             <a:avLst/>
@@ -9157,14 +8635,14 @@
       </p:pic>
       <p:sp>
         <p:nvSpPr>
-          <p:cNvPr id="29" name="Text 23"/>
+          <p:cNvPr id="19" name="Text 13"/>
           <p:cNvSpPr txBox="1"/>
           <p:nvPr/>
         </p:nvSpPr>
         <p:spPr>
           <a:xfrm>
-            <a:off x="1234440" y="5541264"/>
-            <a:ext cx="1874520" cy="310896"/>
+            <a:off x="7498080" y="3758184"/>
+            <a:ext cx="4023360" cy="365760"/>
           </a:xfrm>
           <a:prstGeom prst="rect">
             <a:avLst/>
@@ -9180,72 +8658,72 @@
               <a:buNone/>
             </a:pPr>
             <a:r>
-              <a:rPr lang="en-US" sz="1300" b="1" dirty="0">
+              <a:rPr lang="en-US" sz="1700" b="1" dirty="0">
                 <a:solidFill>
                   <a:schemeClr val="bg1"/>
                 </a:solidFill>
               </a:rPr>
-              <a:t>AUC claro vs. cifrado</a:t>
-            </a:r>
-            <a:endParaRPr lang="en-US" sz="1300" dirty="0"/>
-          </a:p>
-        </p:txBody>
-      </p:sp>
-      <p:sp>
-        <p:nvSpPr>
-          <p:cNvPr id="30" name="Text 24"/>
+              <a:t>128 ms (p50)</a:t>
+            </a:r>
+            <a:endParaRPr lang="en-US" sz="1700" dirty="0"/>
+          </a:p>
+        </p:txBody>
+      </p:sp>
+      <p:sp>
+        <p:nvSpPr>
+          <p:cNvPr id="20" name="Text 14"/>
           <p:cNvSpPr txBox="1"/>
           <p:nvPr/>
         </p:nvSpPr>
         <p:spPr>
           <a:xfrm>
-            <a:off x="1234440" y="5843016"/>
-            <a:ext cx="1874520" cy="237744"/>
-          </a:xfrm>
-          <a:prstGeom prst="rect">
-            <a:avLst/>
-          </a:prstGeom>
-          <a:noFill/>
-          <a:ln/>
-        </p:spPr>
-        <p:txBody>
-          <a:bodyPr wrap="square" lIns="0" tIns="0" rIns="0" bIns="0" rtlCol="0" anchor="ctr"/>
-          <a:lstStyle/>
-          <a:p>
-            <a:pPr indent="0" marL="0">
-              <a:buNone/>
-            </a:pPr>
-            <a:r>
-              <a:rPr lang="en-US" sz="1000" dirty="0">
+            <a:off x="7498080" y="4123944"/>
+            <a:ext cx="4023360" cy="402336"/>
+          </a:xfrm>
+          <a:prstGeom prst="rect">
+            <a:avLst/>
+          </a:prstGeom>
+          <a:noFill/>
+          <a:ln/>
+        </p:spPr>
+        <p:txBody>
+          <a:bodyPr wrap="square" lIns="0" tIns="0" rIns="0" bIns="0" rtlCol="0" anchor="t"/>
+          <a:lstStyle/>
+          <a:p>
+            <a:pPr indent="0" marL="0">
+              <a:buNone/>
+            </a:pPr>
+            <a:r>
+              <a:rPr lang="en-US" sz="1100" dirty="0">
                 <a:solidFill>
                   <a:schemeClr val="bg2"/>
                 </a:solidFill>
               </a:rPr>
-              <a:t>medido en vivo en LinuxONE</a:t>
-            </a:r>
-            <a:endParaRPr lang="en-US" sz="1000" dirty="0"/>
-          </a:p>
-        </p:txBody>
-      </p:sp>
-      <p:sp>
-        <p:nvSpPr>
-          <p:cNvPr id="31" name="Latencia por paciente"/>
+              <a:t>recorrido completo: cifrar, TLS 1.3 mutuo, evaluar, descifrar y bóveda</a:t>
+            </a:r>
+            <a:endParaRPr lang="en-US" sz="1100" dirty="0"/>
+          </a:p>
+        </p:txBody>
+      </p:sp>
+      <p:sp>
+        <p:nvSpPr>
+          <p:cNvPr id="21" name="26.8 KB → 1.4 KB"/>
           <p:cNvSpPr/>
           <p:nvPr/>
         </p:nvSpPr>
         <p:spPr>
           <a:xfrm>
-            <a:off x="3364992" y="5486400"/>
-            <a:ext cx="2642616" cy="658368"/>
+            <a:off x="6720840" y="4709160"/>
+            <a:ext cx="4919472" cy="877824"/>
           </a:xfrm>
           <a:prstGeom prst="roundRect">
             <a:avLst>
-              <a:gd name="adj" fmla="val 13889"/>
+              <a:gd name="adj" fmla="val 10417"/>
             </a:avLst>
           </a:prstGeom>
           <a:solidFill>
             <a:schemeClr val="accent1">
-              <a:alpha val="20000"/>
+              <a:alpha val="15000"/>
             </a:schemeClr>
           </a:solidFill>
           <a:ln/>
@@ -9253,14 +8731,14 @@
       </p:sp>
       <p:sp>
         <p:nvSpPr>
-          <p:cNvPr id="32" name="Latencia por paciente círculo"/>
+          <p:cNvPr id="22" name="26.8 KB → 1.4 KB círculo"/>
           <p:cNvSpPr/>
           <p:nvPr/>
         </p:nvSpPr>
         <p:spPr>
           <a:xfrm>
-            <a:off x="3502152" y="5586984"/>
-            <a:ext cx="457200" cy="457200"/>
+            <a:off x="6858000" y="4892040"/>
+            <a:ext cx="512064" cy="512064"/>
           </a:xfrm>
           <a:prstGeom prst="ellipse">
             <a:avLst/>
@@ -9273,7 +8751,7 @@
       </p:sp>
       <p:pic>
         <p:nvPicPr>
-          <p:cNvPr id="33" name="Latencia por paciente ícono" descr="preencoded.png">    </p:cNvPr>
+          <p:cNvPr id="23" name="26.8 KB → 1.4 KB ícono" descr="preencoded.png">    </p:cNvPr>
           <p:cNvPicPr>
             <a:picLocks noChangeAspect="1"/>
           </p:cNvPicPr>
@@ -9287,8 +8765,8 @@
         </p:blipFill>
         <p:spPr>
           <a:xfrm>
-            <a:off x="3602736" y="5687568"/>
-            <a:ext cx="256032" cy="256032"/>
+            <a:off x="6970654" y="5004694"/>
+            <a:ext cx="286756" cy="286756"/>
           </a:xfrm>
           <a:prstGeom prst="rect">
             <a:avLst/>
@@ -9297,14 +8775,14 @@
       </p:pic>
       <p:sp>
         <p:nvSpPr>
-          <p:cNvPr id="34" name="Text 27"/>
+          <p:cNvPr id="24" name="Text 17"/>
           <p:cNvSpPr txBox="1"/>
           <p:nvPr/>
         </p:nvSpPr>
         <p:spPr>
           <a:xfrm>
-            <a:off x="4050792" y="5541264"/>
-            <a:ext cx="1874520" cy="310896"/>
+            <a:off x="7498080" y="4764024"/>
+            <a:ext cx="4023360" cy="365760"/>
           </a:xfrm>
           <a:prstGeom prst="rect">
             <a:avLst/>
@@ -9320,36 +8798,72 @@
               <a:buNone/>
             </a:pPr>
             <a:r>
-              <a:rPr lang="en-US" sz="1300" b="1" dirty="0">
+              <a:rPr lang="en-US" sz="1700" b="1" dirty="0">
                 <a:solidFill>
                   <a:schemeClr val="bg1"/>
                 </a:solidFill>
               </a:rPr>
-              <a:t>Latencia por paciente</a:t>
-            </a:r>
-            <a:endParaRPr lang="en-US" sz="1300" dirty="0"/>
-          </a:p>
-        </p:txBody>
-      </p:sp>
-      <p:sp>
-        <p:nvSpPr>
-          <p:cNvPr id="35" name="Text 28"/>
+              <a:t>26.8 KB → 1.4 KB</a:t>
+            </a:r>
+            <a:endParaRPr lang="en-US" sz="1700" dirty="0"/>
+          </a:p>
+        </p:txBody>
+      </p:sp>
+      <p:sp>
+        <p:nvSpPr>
+          <p:cNvPr id="25" name="Text 18"/>
           <p:cNvSpPr txBox="1"/>
           <p:nvPr/>
         </p:nvSpPr>
         <p:spPr>
           <a:xfrm>
-            <a:off x="4050792" y="5843016"/>
-            <a:ext cx="1874520" cy="237744"/>
-          </a:xfrm>
-          <a:prstGeom prst="rect">
-            <a:avLst/>
-          </a:prstGeom>
-          <a:noFill/>
-          <a:ln/>
-        </p:spPr>
-        <p:txBody>
-          <a:bodyPr wrap="square" lIns="0" tIns="0" rIns="0" bIns="0" rtlCol="0" anchor="ctr"/>
+            <a:off x="7498080" y="5129784"/>
+            <a:ext cx="4023360" cy="402336"/>
+          </a:xfrm>
+          <a:prstGeom prst="rect">
+            <a:avLst/>
+          </a:prstGeom>
+          <a:noFill/>
+          <a:ln/>
+        </p:spPr>
+        <p:txBody>
+          <a:bodyPr wrap="square" lIns="0" tIns="0" rIns="0" bIns="0" rtlCol="0" anchor="t"/>
+          <a:lstStyle/>
+          <a:p>
+            <a:pPr indent="0" marL="0">
+              <a:buNone/>
+            </a:pPr>
+            <a:r>
+              <a:rPr lang="en-US" sz="1100" dirty="0">
+                <a:solidFill>
+                  <a:schemeClr val="bg2"/>
+                </a:solidFill>
+              </a:rPr>
+              <a:t>solicitud con 21 cifrados → respuesta con el puntaje cifrado</a:t>
+            </a:r>
+            <a:endParaRPr lang="en-US" sz="1100" dirty="0"/>
+          </a:p>
+        </p:txBody>
+      </p:sp>
+      <p:sp>
+        <p:nvSpPr>
+          <p:cNvPr id="26" name="Text 19"/>
+          <p:cNvSpPr txBox="1"/>
+          <p:nvPr/>
+        </p:nvSpPr>
+        <p:spPr>
+          <a:xfrm>
+            <a:off x="6720840" y="5760720"/>
+            <a:ext cx="4919472" cy="411480"/>
+          </a:xfrm>
+          <a:prstGeom prst="rect">
+            <a:avLst/>
+          </a:prstGeom>
+          <a:noFill/>
+          <a:ln/>
+        </p:spPr>
+        <p:txBody>
+          <a:bodyPr wrap="square" lIns="0" tIns="0" rIns="0" bIns="0" rtlCol="0" anchor="t"/>
           <a:lstStyle/>
           <a:p>
             <a:pPr indent="0" marL="0">
@@ -9358,290 +8872,10 @@
             <a:r>
               <a:rPr lang="en-US" sz="1000" dirty="0">
                 <a:solidFill>
-                  <a:schemeClr val="bg2"/>
-                </a:solidFill>
-              </a:rPr>
-              <a:t>medido en vivo en LinuxONE</a:t>
-            </a:r>
-            <a:endParaRPr lang="en-US" sz="1000" dirty="0"/>
-          </a:p>
-        </p:txBody>
-      </p:sp>
-      <p:sp>
-        <p:nvSpPr>
-          <p:cNvPr id="36" name="Tamaño del cifrado"/>
-          <p:cNvSpPr/>
-          <p:nvPr/>
-        </p:nvSpPr>
-        <p:spPr>
-          <a:xfrm>
-            <a:off x="6181344" y="5486400"/>
-            <a:ext cx="2642616" cy="658368"/>
-          </a:xfrm>
-          <a:prstGeom prst="roundRect">
-            <a:avLst>
-              <a:gd name="adj" fmla="val 13889"/>
-            </a:avLst>
-          </a:prstGeom>
-          <a:solidFill>
-            <a:schemeClr val="accent1">
-              <a:alpha val="20000"/>
-            </a:schemeClr>
-          </a:solidFill>
-          <a:ln/>
-        </p:spPr>
-      </p:sp>
-      <p:sp>
-        <p:nvSpPr>
-          <p:cNvPr id="37" name="Tamaño del cifrado círculo"/>
-          <p:cNvSpPr/>
-          <p:nvPr/>
-        </p:nvSpPr>
-        <p:spPr>
-          <a:xfrm>
-            <a:off x="6318504" y="5586984"/>
-            <a:ext cx="457200" cy="457200"/>
-          </a:xfrm>
-          <a:prstGeom prst="ellipse">
-            <a:avLst/>
-          </a:prstGeom>
-          <a:solidFill>
-            <a:schemeClr val="accent1"/>
-          </a:solidFill>
-          <a:ln/>
-        </p:spPr>
-      </p:sp>
-      <p:pic>
-        <p:nvPicPr>
-          <p:cNvPr id="38" name="Tamaño del cifrado ícono" descr="preencoded.png">    </p:cNvPr>
-          <p:cNvPicPr>
-            <a:picLocks noChangeAspect="1"/>
-          </p:cNvPicPr>
-          <p:nvPr/>
-        </p:nvPicPr>
-        <p:blipFill>
-          <a:blip r:embed="rId6"/>
-          <a:stretch>
-            <a:fillRect/>
-          </a:stretch>
-        </p:blipFill>
-        <p:spPr>
-          <a:xfrm>
-            <a:off x="6419088" y="5687568"/>
-            <a:ext cx="256032" cy="256032"/>
-          </a:xfrm>
-          <a:prstGeom prst="rect">
-            <a:avLst/>
-          </a:prstGeom>
-        </p:spPr>
-      </p:pic>
-      <p:sp>
-        <p:nvSpPr>
-          <p:cNvPr id="39" name="Text 31"/>
-          <p:cNvSpPr txBox="1"/>
-          <p:nvPr/>
-        </p:nvSpPr>
-        <p:spPr>
-          <a:xfrm>
-            <a:off x="6867144" y="5541264"/>
-            <a:ext cx="1874520" cy="310896"/>
-          </a:xfrm>
-          <a:prstGeom prst="rect">
-            <a:avLst/>
-          </a:prstGeom>
-          <a:noFill/>
-          <a:ln/>
-        </p:spPr>
-        <p:txBody>
-          <a:bodyPr wrap="square" lIns="0" tIns="0" rIns="0" bIns="0" rtlCol="0" anchor="ctr"/>
-          <a:lstStyle/>
-          <a:p>
-            <a:pPr indent="0" marL="0">
-              <a:buNone/>
-            </a:pPr>
-            <a:r>
-              <a:rPr lang="en-US" sz="1300" b="1" dirty="0">
-                <a:solidFill>
-                  <a:schemeClr val="bg1"/>
-                </a:solidFill>
-              </a:rPr>
-              <a:t>Tamaño del cifrado</a:t>
-            </a:r>
-            <a:endParaRPr lang="en-US" sz="1300" dirty="0"/>
-          </a:p>
-        </p:txBody>
-      </p:sp>
-      <p:sp>
-        <p:nvSpPr>
-          <p:cNvPr id="40" name="Text 32"/>
-          <p:cNvSpPr txBox="1"/>
-          <p:nvPr/>
-        </p:nvSpPr>
-        <p:spPr>
-          <a:xfrm>
-            <a:off x="6867144" y="5843016"/>
-            <a:ext cx="1874520" cy="237744"/>
-          </a:xfrm>
-          <a:prstGeom prst="rect">
-            <a:avLst/>
-          </a:prstGeom>
-          <a:noFill/>
-          <a:ln/>
-        </p:spPr>
-        <p:txBody>
-          <a:bodyPr wrap="square" lIns="0" tIns="0" rIns="0" bIns="0" rtlCol="0" anchor="ctr"/>
-          <a:lstStyle/>
-          <a:p>
-            <a:pPr indent="0" marL="0">
-              <a:buNone/>
-            </a:pPr>
-            <a:r>
-              <a:rPr lang="en-US" sz="1000" dirty="0">
-                <a:solidFill>
-                  <a:schemeClr val="bg2"/>
-                </a:solidFill>
-              </a:rPr>
-              <a:t>medido en vivo en LinuxONE</a:t>
-            </a:r>
-            <a:endParaRPr lang="en-US" sz="1000" dirty="0"/>
-          </a:p>
-        </p:txBody>
-      </p:sp>
-      <p:sp>
-        <p:nvSpPr>
-          <p:cNvPr id="41" name="Pacientes por minuto"/>
-          <p:cNvSpPr/>
-          <p:nvPr/>
-        </p:nvSpPr>
-        <p:spPr>
-          <a:xfrm>
-            <a:off x="8997696" y="5486400"/>
-            <a:ext cx="2642616" cy="658368"/>
-          </a:xfrm>
-          <a:prstGeom prst="roundRect">
-            <a:avLst>
-              <a:gd name="adj" fmla="val 13889"/>
-            </a:avLst>
-          </a:prstGeom>
-          <a:solidFill>
-            <a:schemeClr val="accent1">
-              <a:alpha val="20000"/>
-            </a:schemeClr>
-          </a:solidFill>
-          <a:ln/>
-        </p:spPr>
-      </p:sp>
-      <p:sp>
-        <p:nvSpPr>
-          <p:cNvPr id="42" name="Pacientes por minuto círculo"/>
-          <p:cNvSpPr/>
-          <p:nvPr/>
-        </p:nvSpPr>
-        <p:spPr>
-          <a:xfrm>
-            <a:off x="9134856" y="5586984"/>
-            <a:ext cx="457200" cy="457200"/>
-          </a:xfrm>
-          <a:prstGeom prst="ellipse">
-            <a:avLst/>
-          </a:prstGeom>
-          <a:solidFill>
-            <a:schemeClr val="accent1"/>
-          </a:solidFill>
-          <a:ln/>
-        </p:spPr>
-      </p:sp>
-      <p:pic>
-        <p:nvPicPr>
-          <p:cNvPr id="43" name="Pacientes por minuto ícono" descr="preencoded.png">    </p:cNvPr>
-          <p:cNvPicPr>
-            <a:picLocks noChangeAspect="1"/>
-          </p:cNvPicPr>
-          <p:nvPr/>
-        </p:nvPicPr>
-        <p:blipFill>
-          <a:blip r:embed="rId7"/>
-          <a:stretch>
-            <a:fillRect/>
-          </a:stretch>
-        </p:blipFill>
-        <p:spPr>
-          <a:xfrm>
-            <a:off x="9235440" y="5687568"/>
-            <a:ext cx="256032" cy="256032"/>
-          </a:xfrm>
-          <a:prstGeom prst="rect">
-            <a:avLst/>
-          </a:prstGeom>
-        </p:spPr>
-      </p:pic>
-      <p:sp>
-        <p:nvSpPr>
-          <p:cNvPr id="44" name="Text 35"/>
-          <p:cNvSpPr txBox="1"/>
-          <p:nvPr/>
-        </p:nvSpPr>
-        <p:spPr>
-          <a:xfrm>
-            <a:off x="9683496" y="5541264"/>
-            <a:ext cx="1874520" cy="310896"/>
-          </a:xfrm>
-          <a:prstGeom prst="rect">
-            <a:avLst/>
-          </a:prstGeom>
-          <a:noFill/>
-          <a:ln/>
-        </p:spPr>
-        <p:txBody>
-          <a:bodyPr wrap="square" lIns="0" tIns="0" rIns="0" bIns="0" rtlCol="0" anchor="ctr"/>
-          <a:lstStyle/>
-          <a:p>
-            <a:pPr indent="0" marL="0">
-              <a:buNone/>
-            </a:pPr>
-            <a:r>
-              <a:rPr lang="en-US" sz="1300" b="1" dirty="0">
-                <a:solidFill>
-                  <a:schemeClr val="bg1"/>
-                </a:solidFill>
-              </a:rPr>
-              <a:t>Pacientes por minuto</a:t>
-            </a:r>
-            <a:endParaRPr lang="en-US" sz="1300" dirty="0"/>
-          </a:p>
-        </p:txBody>
-      </p:sp>
-      <p:sp>
-        <p:nvSpPr>
-          <p:cNvPr id="45" name="Text 36"/>
-          <p:cNvSpPr txBox="1"/>
-          <p:nvPr/>
-        </p:nvSpPr>
-        <p:spPr>
-          <a:xfrm>
-            <a:off x="9683496" y="5843016"/>
-            <a:ext cx="1874520" cy="237744"/>
-          </a:xfrm>
-          <a:prstGeom prst="rect">
-            <a:avLst/>
-          </a:prstGeom>
-          <a:noFill/>
-          <a:ln/>
-        </p:spPr>
-        <p:txBody>
-          <a:bodyPr wrap="square" lIns="0" tIns="0" rIns="0" bIns="0" rtlCol="0" anchor="ctr"/>
-          <a:lstStyle/>
-          <a:p>
-            <a:pPr indent="0" marL="0">
-              <a:buNone/>
-            </a:pPr>
-            <a:r>
-              <a:rPr lang="en-US" sz="1000" dirty="0">
-                <a:solidFill>
-                  <a:schemeClr val="bg2"/>
-                </a:solidFill>
-              </a:rPr>
-              <a:t>medido en vivo en LinuxONE</a:t>
+                  <a:schemeClr val="accent4"/>
+                </a:solidFill>
+              </a:rPr>
+              <a:t>Medición LOCAL (macOS arm64, llave de 2048 bits). En LinuxONE se vuelve a medir con make medir-docker.</a:t>
             </a:r>
             <a:endParaRPr lang="en-US" sz="1000" dirty="0"/>
           </a:p>
@@ -10220,7 +9454,7 @@
                   <a:schemeClr val="bg2"/>
                 </a:solidFill>
               </a:rPr>
-              <a:t>Regresión logística (y XGBoost en claro como referencia)</a:t>
+              <a:t>Regresión logística; la estandarización se pliega en los pesos</a:t>
             </a:r>
             <a:endParaRPr lang="en-US" sz="1200" dirty="0"/>
           </a:p>
@@ -10371,7 +9605,7 @@
                   <a:schemeClr val="bg2"/>
                 </a:solidFill>
               </a:rPr>
-              <a:t>Enteros que el esquema cifrado puede operar</a:t>
+              <a:t>Pesos × 10⁹ redondeados; las 21 entradas ya son enteros</a:t>
             </a:r>
             <a:endParaRPr lang="en-US" sz="1200" dirty="0"/>
           </a:p>
@@ -10686,7 +9920,7 @@
                   <a:schemeClr val="accent5"/>
                 </a:solidFill>
               </a:rPr>
-              <a:t>CÓMO LO MEDIMOS · RESULTADOS EN VIVO EN LA DEMO</a:t>
+              <a:t>RESULTADOS EN PRUEBA (38,052 PERSONAS)</a:t>
             </a:r>
             <a:endParaRPr lang="en-US" sz="1100" dirty="0"/>
           </a:p>
@@ -10833,7 +10067,7 @@
                   <a:schemeClr val="bg2"/>
                 </a:solidFill>
               </a:rPr>
-              <a:t>AUC, AUC-PR, sensibilidad y especificidad con umbral fijado en validación, calibración, error claro vs. cifrado y latencia p50/p95, con el tamaño de la muestra.</a:t>
+              <a:t>ROC-AUC 0.826 · AP 0.415 · sensibilidad 0.805 · especificidad 0.691 · Brier 0.098, con umbral fijado en validación. Punto fijo: error máximo 5.7×10⁻⁸ en el logit.</a:t>
             </a:r>
             <a:endParaRPr lang="en-US" sz="1200" dirty="0"/>
           </a:p>

</xml_diff>

<commit_message>
pitch: límites con el resultado de ENSANUT; estado de CKKS y Granite con evidencia
</commit_message>
<xml_diff>
--- a/submission/Los_Antimarrulla_Pitch_Tamizaje.pptx
+++ b/submission/Los_Antimarrulla_Pitch_Tamizaje.pptx
@@ -114,30 +114,30 @@
   <p:extLst>
     <p:ext uri="{521415D9-36F7-43E2-AB2F-B90AF26B5E84}">
       <p14:sectionLst xmlns:p14="http://schemas.microsoft.com/office/powerpoint/2010/main">
-        <p14:section name="Portada" id="{03748e31-4eca-495e-bd01-836fbc85ee25}">
+        <p14:section name="Portada" id="{c36a028a-45ef-008c-63ba-396927b28648}">
           <p14:sldIdLst>
             <p14:sldId id="256"/>
           </p14:sldIdLst>
         </p14:section>
-        <p14:section name="Problema y solución" id="{58ce8105-2dd0-9662-3630-6e00c0a535e5}">
+        <p14:section name="Problema y solución" id="{7add40ef-d063-4c1f-7fca-95d931624ee4}">
           <p14:sldIdLst>
             <p14:sldId id="257"/>
             <p14:sldId id="258"/>
           </p14:sldIdLst>
         </p14:section>
-        <p14:section name="Tecnología" id="{6b1cfbf7-d3d9-cb28-765c-fb7a7f219145}">
+        <p14:section name="Tecnología" id="{ed984eea-0bff-45d2-bf7e-d9841b0232bc}">
           <p14:sldIdLst>
             <p14:sldId id="259"/>
             <p14:sldId id="260"/>
           </p14:sldIdLst>
         </p14:section>
-        <p14:section name="Demo y datos" id="{d1f72b02-9b6c-2798-49f8-669a5c00bcbd}">
+        <p14:section name="Demo y datos" id="{f850f602-12a5-05b4-fb81-da2474e39d22}">
           <p14:sldIdLst>
             <p14:sldId id="261"/>
             <p14:sldId id="262"/>
           </p14:sldIdLst>
         </p14:section>
-        <p14:section name="Impacto y cierre" id="{24f8c381-0d52-e82b-77d9-010db1d541b6}">
+        <p14:section name="Impacto y cierre" id="{07424395-a378-4805-abb8-b237cd728b6c}">
           <p14:sldIdLst>
             <p14:sldId id="263"/>
           </p14:sldIdLst>
@@ -1074,7 +1074,7 @@
           <a:p>
             <a:r>
               <a:rPr lang="en-US" dirty="0"/>
-              <a:t>Entrenamos con 253 mil registros públicos de los CDC: AUC 0.83 en prueba y 80% de sensibilidad con el umbral fijado en validación. Los datos de pacientes solo llegan cifrados. (Es una prueba técnica con datos de EE. UU.; la evaluación externa exploratoria con ENSANUT está pendiente.)</a:t>
+              <a:t>Entrenamos con 253 mil registros públicos de los CDC: AUC 0.83 en prueba y 80% de sensibilidad con el umbral fijado en validación. Los datos de pacientes solo llegan cifrados. (Límite honesto: en un experimento exploratorio con adultos mexicanos de ENSANUT, un modelo reducido baja a AUC 0.77 y subestima el riesgo; para usarlo en México habría que recalibrar.)</a:t>
             </a:r>
             <a:endParaRPr lang="en-US" dirty="0"/>
           </a:p>
@@ -10214,7 +10214,7 @@
                   <a:schemeClr val="bg2"/>
                 </a:solidFill>
               </a:rPr>
-              <a:t>Datos de EE. UU. y diagnóstico declarado: es una prueba técnica. Evaluación externa exploratoria con ENSANUT: pendiente.</a:t>
+              <a:t>Prueba técnica con datos de EE. UU. En adultos mexicanos (ENSANUT, exploratorio) el AUC baja a 0.77 y el riesgo se subestima: habría que recalibrar.</a:t>
             </a:r>
             <a:endParaRPr lang="en-US" sz="1200" dirty="0"/>
           </a:p>

</xml_diff>

<commit_message>
docs: una sola descripción del sistema (bóveda en el hospital, sin CPACF ni escala no medidos), contrato único, ENSANUT como modelo reducido aparte, E5 con evaluación real y deck regenerado (auditoría 3: F04, F09)
</commit_message>
<xml_diff>
--- a/submission/Los_Antimarrulla_Pitch_Tamizaje.pptx
+++ b/submission/Los_Antimarrulla_Pitch_Tamizaje.pptx
@@ -114,30 +114,30 @@
   <p:extLst>
     <p:ext uri="{521415D9-36F7-43E2-AB2F-B90AF26B5E84}">
       <p14:sectionLst xmlns:p14="http://schemas.microsoft.com/office/powerpoint/2010/main">
-        <p14:section name="Portada" id="{c36a028a-45ef-008c-63ba-396927b28648}">
+        <p14:section name="Portada" id="{7a0cb8f3-2318-d3f9-82f5-e2c124febf52}">
           <p14:sldIdLst>
             <p14:sldId id="256"/>
           </p14:sldIdLst>
         </p14:section>
-        <p14:section name="Problema y solución" id="{7add40ef-d063-4c1f-7fca-95d931624ee4}">
+        <p14:section name="Problema y solución" id="{87d3639b-a87b-34f4-36e7-ffac93641199}">
           <p14:sldIdLst>
             <p14:sldId id="257"/>
             <p14:sldId id="258"/>
           </p14:sldIdLst>
         </p14:section>
-        <p14:section name="Tecnología" id="{ed984eea-0bff-45d2-bf7e-d9841b0232bc}">
+        <p14:section name="Tecnología" id="{fc5e3c4c-0a38-67cf-4f78-ad3f47106798}">
           <p14:sldIdLst>
             <p14:sldId id="259"/>
             <p14:sldId id="260"/>
           </p14:sldIdLst>
         </p14:section>
-        <p14:section name="Demo y datos" id="{f850f602-12a5-05b4-fb81-da2474e39d22}">
+        <p14:section name="Demo y datos" id="{7b922e00-cedc-7287-5b6e-4f5d55633659}">
           <p14:sldIdLst>
             <p14:sldId id="261"/>
             <p14:sldId id="262"/>
           </p14:sldIdLst>
         </p14:section>
-        <p14:section name="Impacto y cierre" id="{07424395-a378-4805-abb8-b237cd728b6c}">
+        <p14:section name="Impacto y cierre" id="{d91d437b-0c1a-9298-6dc8-125afd8e4ea6}">
           <p14:sldIdLst>
             <p14:sldId id="263"/>
           </p14:sldIdLst>
@@ -898,7 +898,7 @@
           <a:p>
             <a:r>
               <a:rPr lang="en-US" dirty="0"/>
-              <a:t>Mostrar la terminal de la VM: uname -m → s390x y los dos contenedores corriendo. Todo corre en LinuxONE, en dos contenedores: el del hospital, con la llave, y el servicio de riesgo, sin ella; entre ellos, TLS 1.3 mutuo. En la demo comparten VM; en producción, el del hospital vive en sus instalaciones. La aritmética homomórfica son exponenciaciones con enteros de miles de bits: cómputo pesado, justo para IBM Z.</a:t>
+              <a:t>Mostrar la terminal de la VM SOLO cuando ya se haya corrido ahí (docs/LINUXONE.md): uname -m → s390x y los dos contenedores. El diseño: dos contenedores, el del hospital con la llave Paillier y la bóveda AES, y el servicio de riesgo sin llaves; entre ellos, TLS 1.3 mutuo. En la demo comparten VM; en producción, el del hospital vive en sus instalaciones. La aritmética homomórfica son exponenciaciones con enteros de miles de bits. CPACF existe en IBM Z, pero su uso efectivo por nuestra biblioteca no está medido: no decir que lo acelera.</a:t>
             </a:r>
             <a:endParaRPr lang="en-US" dirty="0"/>
           </a:p>
@@ -986,7 +986,7 @@
           <a:p>
             <a:r>
               <a:rPr lang="en-US" dirty="0"/>
-              <a:t>Esta es la demo real. A la izquierda, lo que ve el servicio de riesgo: 21 números cifrados y el puntaje cifrado que devuelve. A la derecha, lo que ve el hospital: el riesgo, la decisión frente al umbral y los factores que más pesan. En 2,000 pacientes de prueba, los 2,000 resultados descifrados son idénticos a la referencia y el AUC es el mismo cifrado que en claro: 0.808. Cifras locales; en el video se muestran las de LinuxONE.</a:t>
+              <a:t>Esta es la demo real. A la izquierda, lo que ve el servicio de riesgo: 21 números cifrados y el puntaje cifrado que devuelve. A la derecha, lo que ve el hospital: el riesgo, la decisión frente al umbral y los factores que más pesan. En 2,000 pacientes de prueba, los 2,000 enteros descifrados son idénticos a la referencia y el AUC cifrado es igual al de claro: 0.808. Cifras locales y trazables; en el video se muestran las de LinuxONE.</a:t>
             </a:r>
             <a:endParaRPr lang="en-US" dirty="0"/>
           </a:p>
@@ -5063,7 +5063,7 @@
                   <a:schemeClr val="bg2"/>
                 </a:solidFill>
               </a:rPr>
-              <a:t>TLS 1.3 entre el hospital y LinuxONE</a:t>
+              <a:t>TLS 1.3 mutuo entre hospital y servicio</a:t>
             </a:r>
             <a:endParaRPr lang="en-US" sz="1200" dirty="0"/>
           </a:p>
@@ -5208,7 +5208,7 @@
                   <a:schemeClr val="bg2"/>
                 </a:solidFill>
               </a:rPr>
-              <a:t>AES-256-GCM acelerado por hardware (CPACF de IBM Z)</a:t>
+              <a:t>AES-256-GCM en la bóveda del hospital</a:t>
             </a:r>
             <a:endParaRPr lang="en-US" sz="1200" dirty="0"/>
           </a:p>
@@ -6040,7 +6040,7 @@
                           <a:ea typeface="Arial" pitchFamily="34" charset="-122"/>
                           <a:cs typeface="Arial" pitchFamily="34" charset="-120"/>
                         </a:rPr>
-                        <a:t>Disco, logs y respaldos</a:t>
+                        <a:t>Registros de la bóveda (hospital)</a:t>
                       </a:r>
                       <a:endParaRPr lang="en-US" sz="1200" dirty="0">
                         <a:latin typeface="Arial" charset="0"/>
@@ -6237,7 +6237,7 @@
                           <a:ea typeface="Arial" pitchFamily="34" charset="-122"/>
                           <a:cs typeface="Arial" pitchFamily="34" charset="-120"/>
                         </a:rPr>
-                        <a:t>Explicación (entorno del hospital)</a:t>
+                        <a:t>Logs del servicio</a:t>
                       </a:r>
                       <a:endParaRPr lang="en-US" sz="1200" dirty="0">
                         <a:latin typeface="Arial" charset="0"/>
@@ -6294,15 +6294,15 @@
                         <a:buNone/>
                       </a:pPr>
                       <a:r>
-                        <a:rPr lang="en-US" sz="1200" dirty="0">
+                        <a:rPr lang="en-US" sz="1200" b="1" dirty="0">
                           <a:solidFill>
-                            <a:schemeClr val="bg2"/>
+                            <a:schemeClr val="accent2"/>
                           </a:solidFill>
                           <a:latin typeface="Arial" pitchFamily="34" charset="0"/>
                           <a:ea typeface="Arial" pitchFamily="34" charset="-122"/>
                           <a:cs typeface="Arial" pitchFamily="34" charset="-120"/>
                         </a:rPr>
-                        <a:t>Solo el hospital</a:t>
+                        <a:t>No: solo id, ms y bytes</a:t>
                       </a:r>
                       <a:endParaRPr lang="en-US" sz="1200" dirty="0">
                         <a:latin typeface="Arial" charset="0"/>
@@ -6359,15 +6359,15 @@
                         <a:buNone/>
                       </a:pPr>
                       <a:r>
-                        <a:rPr lang="en-US" sz="1200" dirty="0">
+                        <a:rPr lang="en-US" sz="1200" b="1" dirty="0">
                           <a:solidFill>
-                            <a:schemeClr val="bg2"/>
+                            <a:schemeClr val="accent2"/>
                           </a:solidFill>
                           <a:latin typeface="Arial" pitchFamily="34" charset="0"/>
                           <a:ea typeface="Arial" pitchFamily="34" charset="-122"/>
                           <a:cs typeface="Arial" pitchFamily="34" charset="-120"/>
                         </a:rPr>
-                        <a:t>Resultado descifrado</a:t>
+                        <a:t>No</a:t>
                       </a:r>
                       <a:endParaRPr lang="en-US" sz="1200" dirty="0">
                         <a:latin typeface="Arial" charset="0"/>
@@ -7057,7 +7057,7 @@
       </p:sp>
       <p:sp>
         <p:nvSpPr>
-          <p:cNvPr id="20" name="Cifrar y descifrar"/>
+          <p:cNvPr id="20" name="Cifrar, descifrar, explicar"/>
           <p:cNvSpPr/>
           <p:nvPr/>
         </p:nvSpPr>
@@ -7109,7 +7109,7 @@
                   <a:schemeClr val="bg1"/>
                 </a:solidFill>
               </a:rPr>
-              <a:t>Cifrar y descifrar</a:t>
+              <a:t>Cifrar, descifrar, explicar</a:t>
             </a:r>
             <a:endParaRPr lang="en-US" sz="1200" dirty="0"/>
           </a:p>
@@ -7145,7 +7145,7 @@
                   <a:schemeClr val="bg2"/>
                 </a:solidFill>
               </a:rPr>
-              <a:t>python-paillier</a:t>
+              <a:t>python-paillier + gmpy2</a:t>
             </a:r>
             <a:endParaRPr lang="en-US" sz="1000" dirty="0"/>
           </a:p>
@@ -7153,7 +7153,7 @@
       </p:sp>
       <p:sp>
         <p:nvSpPr>
-          <p:cNvPr id="23" name="Explicación"/>
+          <p:cNvPr id="23" name="Bóveda cifrada"/>
           <p:cNvSpPr/>
           <p:nvPr/>
         </p:nvSpPr>
@@ -7205,7 +7205,7 @@
                   <a:schemeClr val="bg1"/>
                 </a:solidFill>
               </a:rPr>
-              <a:t>Explicación</a:t>
+              <a:t>Bóveda cifrada</a:t>
             </a:r>
             <a:endParaRPr lang="en-US" sz="1200" dirty="0"/>
           </a:p>
@@ -7236,12 +7236,12 @@
               <a:buNone/>
             </a:pPr>
             <a:r>
-              <a:rPr lang="en-US" sz="1000" dirty="0">
-                <a:solidFill>
-                  <a:schemeClr val="bg2"/>
-                </a:solidFill>
-              </a:rPr>
-              <a:t>factores que más pesan</a:t>
+              <a:rPr lang="en-US" sz="1000" b="1" dirty="0">
+                <a:solidFill>
+                  <a:schemeClr val="accent2"/>
+                </a:solidFill>
+              </a:rPr>
+              <a:t>AES-256-GCM · llave externa</a:t>
             </a:r>
             <a:endParaRPr lang="en-US" sz="1000" dirty="0"/>
           </a:p>
@@ -7402,7 +7402,7 @@
                   <a:schemeClr val="bg2"/>
                 </a:solidFill>
               </a:rPr>
-              <a:t>pesos en punto fijo</a:t>
+              <a:t>pesos enteros × 10⁹</a:t>
             </a:r>
             <a:endParaRPr lang="en-US" sz="1000" dirty="0"/>
           </a:p>
@@ -7498,7 +7498,7 @@
                   <a:schemeClr val="bg2"/>
                 </a:solidFill>
               </a:rPr>
-              <a:t>enteros de 4096 bits</a:t>
+              <a:t>enteros de 4096 bits (mod n²)</a:t>
             </a:r>
             <a:endParaRPr lang="en-US" sz="1000" dirty="0"/>
           </a:p>
@@ -7506,7 +7506,7 @@
       </p:sp>
       <p:sp>
         <p:nvSpPr>
-          <p:cNvPr id="34" name="Bóveda cifrada"/>
+          <p:cNvPr id="34" name="Logs mínimos"/>
           <p:cNvSpPr/>
           <p:nvPr/>
         </p:nvSpPr>
@@ -7558,7 +7558,7 @@
                   <a:schemeClr val="bg1"/>
                 </a:solidFill>
               </a:rPr>
-              <a:t>Bóveda cifrada</a:t>
+              <a:t>Logs mínimos</a:t>
             </a:r>
             <a:endParaRPr lang="en-US" sz="1200" dirty="0"/>
           </a:p>
@@ -7589,12 +7589,12 @@
               <a:buNone/>
             </a:pPr>
             <a:r>
-              <a:rPr lang="en-US" sz="1000" b="1" dirty="0">
-                <a:solidFill>
-                  <a:schemeClr val="accent2"/>
-                </a:solidFill>
-              </a:rPr>
-              <a:t>AES-256-GCM · CPACF</a:t>
+              <a:rPr lang="en-US" sz="1000" dirty="0">
+                <a:solidFill>
+                  <a:schemeClr val="bg2"/>
+                </a:solidFill>
+              </a:rPr>
+              <a:t>id, ms y bytes; sin datos</a:t>
             </a:r>
             <a:endParaRPr lang="en-US" sz="1000" dirty="0"/>
           </a:p>
@@ -7794,7 +7794,7 @@
                   <a:schemeClr val="bg2"/>
                 </a:solidFill>
               </a:rPr>
-              <a:t>Cada paciente implica exponenciaciones modulares con enteros enormes</a:t>
+              <a:t>Exponenciaciones modulares con enteros de miles de bits por paciente</a:t>
             </a:r>
             <a:endParaRPr lang="en-US" sz="1200" dirty="0"/>
           </a:p>
@@ -7802,7 +7802,7 @@
       </p:sp>
       <p:sp>
         <p:nvSpPr>
-          <p:cNvPr id="44" name="Seguridad de nivel bancario círculo"/>
+          <p:cNvPr id="44" name="Aislamiento y cifrado círculo"/>
           <p:cNvSpPr/>
           <p:nvPr/>
         </p:nvSpPr>
@@ -7822,7 +7822,7 @@
       </p:sp>
       <p:pic>
         <p:nvPicPr>
-          <p:cNvPr id="45" name="Seguridad de nivel bancario ícono" descr="preencoded.png">    </p:cNvPr>
+          <p:cNvPr id="45" name="Aislamiento y cifrado ícono" descr="preencoded.png">    </p:cNvPr>
           <p:cNvPicPr>
             <a:picLocks noChangeAspect="1"/>
           </p:cNvPicPr>
@@ -7874,7 +7874,7 @@
                   <a:schemeClr val="bg1"/>
                 </a:solidFill>
               </a:rPr>
-              <a:t>Seguridad de nivel bancario</a:t>
+              <a:t>Aislamiento y cifrado</a:t>
             </a:r>
             <a:endParaRPr lang="en-US" sz="1400" dirty="0"/>
           </a:p>
@@ -7910,7 +7910,7 @@
                   <a:schemeClr val="bg2"/>
                 </a:solidFill>
               </a:rPr>
-              <a:t>Cifrado por hardware y aislamiento entre cargas de trabajo</a:t>
+              <a:t>Contenedores separados y TLS mutuo; CPACF existe en IBM Z, su uso efectivo falta medirlo</a:t>
             </a:r>
             <a:endParaRPr lang="en-US" sz="1200" dirty="0"/>
           </a:p>
@@ -7918,7 +7918,7 @@
       </p:sp>
       <p:sp>
         <p:nvSpPr>
-          <p:cNvPr id="48" name="Escala por lotes círculo"/>
+          <p:cNvPr id="48" name="Medido, no prometido círculo"/>
           <p:cNvSpPr/>
           <p:nvPr/>
         </p:nvSpPr>
@@ -7938,7 +7938,7 @@
       </p:sp>
       <p:pic>
         <p:nvPicPr>
-          <p:cNvPr id="49" name="Escala por lotes ícono" descr="preencoded.png">    </p:cNvPr>
+          <p:cNvPr id="49" name="Medido, no prometido ícono" descr="preencoded.png">    </p:cNvPr>
           <p:cNvPicPr>
             <a:picLocks noChangeAspect="1"/>
           </p:cNvPicPr>
@@ -7990,7 +7990,7 @@
                   <a:schemeClr val="bg1"/>
                 </a:solidFill>
               </a:rPr>
-              <a:t>Escala por lotes</a:t>
+              <a:t>Medido, no prometido</a:t>
             </a:r>
             <a:endParaRPr lang="en-US" sz="1400" dirty="0"/>
           </a:p>
@@ -8026,7 +8026,7 @@
                   <a:schemeClr val="bg2"/>
                 </a:solidFill>
               </a:rPr>
-              <a:t>Muchos pacientes en una sola plataforma; se mide en LinuxONE</a:t>
+              <a:t>Hoy ~460 pacientes/min en secuencia (local); en LinuxONE se mide igual</a:t>
             </a:r>
             <a:endParaRPr lang="en-US" sz="1200" dirty="0"/>
           </a:p>
@@ -8279,7 +8279,7 @@
                   <a:schemeClr val="accent6"/>
                 </a:solidFill>
               </a:rPr>
-              <a:t>Captura real de la UI con un paciente sintético (contenedores locales, 17 oct)</a:t>
+              <a:t>Captura real de la UI con un paciente sintético (contenedores locales, commit 7937f9f)</a:t>
             </a:r>
             <a:endParaRPr lang="en-US" sz="1000" dirty="0"/>
           </a:p>
@@ -8419,7 +8419,7 @@
                   <a:schemeClr val="bg2"/>
                 </a:solidFill>
               </a:rPr>
-              <a:t>enteros descifrados idénticos a la referencia (error cero)</a:t>
+              <a:t>enteros descifrados idénticos a la referencia de punto fijo</a:t>
             </a:r>
             <a:endParaRPr lang="en-US" sz="1100" dirty="0"/>
           </a:p>
@@ -8567,7 +8567,7 @@
       </p:sp>
       <p:sp>
         <p:nvSpPr>
-          <p:cNvPr id="16" name="128 ms (p50)"/>
+          <p:cNvPr id="16" name="129 ms (p50)"/>
           <p:cNvSpPr/>
           <p:nvPr/>
         </p:nvSpPr>
@@ -8591,7 +8591,7 @@
       </p:sp>
       <p:sp>
         <p:nvSpPr>
-          <p:cNvPr id="17" name="128 ms (p50) círculo"/>
+          <p:cNvPr id="17" name="129 ms (p50) círculo"/>
           <p:cNvSpPr/>
           <p:nvPr/>
         </p:nvSpPr>
@@ -8611,7 +8611,7 @@
       </p:sp>
       <p:pic>
         <p:nvPicPr>
-          <p:cNvPr id="18" name="128 ms (p50) ícono" descr="preencoded.png">    </p:cNvPr>
+          <p:cNvPr id="18" name="129 ms (p50) ícono" descr="preencoded.png">    </p:cNvPr>
           <p:cNvPicPr>
             <a:picLocks noChangeAspect="1"/>
           </p:cNvPicPr>
@@ -8663,7 +8663,7 @@
                   <a:schemeClr val="bg1"/>
                 </a:solidFill>
               </a:rPr>
-              <a:t>128 ms (p50)</a:t>
+              <a:t>129 ms (p50)</a:t>
             </a:r>
             <a:endParaRPr lang="en-US" sz="1700" dirty="0"/>
           </a:p>
@@ -8699,7 +8699,7 @@
                   <a:schemeClr val="bg2"/>
                 </a:solidFill>
               </a:rPr>
-              <a:t>recorrido completo: cifrar, TLS 1.3 mutuo, evaluar, descifrar y bóveda</a:t>
+              <a:t>API del hospital en dos contenedores: cifrar, mTLS, evaluar, descifrar y bóveda (200 sintéticos)</a:t>
             </a:r>
             <a:endParaRPr lang="en-US" sz="1100" dirty="0"/>
           </a:p>
@@ -8875,7 +8875,7 @@
                   <a:schemeClr val="accent4"/>
                 </a:solidFill>
               </a:rPr>
-              <a:t>Medición LOCAL (macOS arm64, llave de 2048 bits). En LinuxONE se vuelve a medir con make medir-docker.</a:t>
+              <a:t>Medición LOCAL trazable (commit 7937f9f, macOS arm64 y Docker; llave de 2048 bits). No es LinuxONE: allá se mide con make medir-api-docker.</a:t>
             </a:r>
             <a:endParaRPr lang="en-US" sz="1000" dirty="0"/>
           </a:p>
@@ -10067,7 +10067,7 @@
                   <a:schemeClr val="bg2"/>
                 </a:solidFill>
               </a:rPr>
-              <a:t>ROC-AUC 0.826 · AP 0.415 · sensibilidad 0.805 · especificidad 0.691 · Brier 0.098, con umbral fijado en validación. Punto fijo: error máximo 5.7×10⁻⁸ en el logit.</a:t>
+              <a:t>ROC-AUC 0.826 · AP 0.415 · sensibilidad 0.805 · especificidad 0.691 · VPP 0.297 · Brier 0.098, con umbral fijado en validación.</a:t>
             </a:r>
             <a:endParaRPr lang="en-US" sz="1200" dirty="0"/>
           </a:p>
@@ -10214,7 +10214,7 @@
                   <a:schemeClr val="bg2"/>
                 </a:solidFill>
               </a:rPr>
-              <a:t>Prueba técnica con datos de EE. UU. En adultos mexicanos (ENSANUT, exploratorio) el AUC baja a 0.77 y el riesgo se subestima: habría que recalibrar.</a:t>
+              <a:t>Etiqueta: diagnóstico declarado en EE. UU., no diabetes futura. Otro modelo reducido (10 variables) baja a AUC 0.77 en ENSANUT y subestima el riesgo.</a:t>
             </a:r>
             <a:endParaRPr lang="en-US" sz="1200" dirty="0"/>
           </a:p>

</xml_diff>

<commit_message>
fix: modo final valida contenido de mediciones, labs, LinuxONE, video y revisión; --final exige limpieza demostrada; id con fullmatch; hash del código desplegado en la API; LinuxONE como destino en textos y deck (validación 4: R1, R2, R3)
</commit_message>
<xml_diff>
--- a/submission/Los_Antimarrulla_Pitch_Tamizaje.pptx
+++ b/submission/Los_Antimarrulla_Pitch_Tamizaje.pptx
@@ -114,30 +114,30 @@
   <p:extLst>
     <p:ext uri="{521415D9-36F7-43E2-AB2F-B90AF26B5E84}">
       <p14:sectionLst xmlns:p14="http://schemas.microsoft.com/office/powerpoint/2010/main">
-        <p14:section name="Portada" id="{7a0cb8f3-2318-d3f9-82f5-e2c124febf52}">
+        <p14:section name="Portada" id="{1f7f14b0-0a57-c98d-2507-697c565397eb}">
           <p14:sldIdLst>
             <p14:sldId id="256"/>
           </p14:sldIdLst>
         </p14:section>
-        <p14:section name="Problema y solución" id="{87d3639b-a87b-34f4-36e7-ffac93641199}">
+        <p14:section name="Problema y solución" id="{bbf9456e-7b2a-573f-4b55-da6dd8050d63}">
           <p14:sldIdLst>
             <p14:sldId id="257"/>
             <p14:sldId id="258"/>
           </p14:sldIdLst>
         </p14:section>
-        <p14:section name="Tecnología" id="{fc5e3c4c-0a38-67cf-4f78-ad3f47106798}">
+        <p14:section name="Tecnología" id="{2b930f3b-46a0-7377-279a-17a0c0e81cf8}">
           <p14:sldIdLst>
             <p14:sldId id="259"/>
             <p14:sldId id="260"/>
           </p14:sldIdLst>
         </p14:section>
-        <p14:section name="Demo y datos" id="{7b922e00-cedc-7287-5b6e-4f5d55633659}">
+        <p14:section name="Demo y datos" id="{438daaba-6b57-4826-5ef7-db82f4be73cc}">
           <p14:sldIdLst>
             <p14:sldId id="261"/>
             <p14:sldId id="262"/>
           </p14:sldIdLst>
         </p14:section>
-        <p14:section name="Impacto y cierre" id="{d91d437b-0c1a-9298-6dc8-125afd8e4ea6}">
+        <p14:section name="Impacto y cierre" id="{df54d44a-fe5b-9230-4c22-d3b521b2f002}">
           <p14:sldIdLst>
             <p14:sldId id="263"/>
           </p14:sldIdLst>
@@ -722,7 +722,7 @@
           <a:p>
             <a:r>
               <a:rPr lang="en-US" dirty="0"/>
-              <a:t>El hospital cifra los 21 indicadores del paciente y se queda con la llave. LinuxONE calcula el riesgo sobre números cifrados; solo el hospital abre el resultado y ve los factores que más pesan. Es tamizaje: decide a quién hacerle primero una prueba de glucosa. (Alcance: el servicio de riesgo solo recibe cifrados; en la demo, quien administra la VM queda dentro del entorno de confianza y usamos pacientes sintéticos.)</a:t>
+              <a:t>El hospital cifra los 21 indicadores del paciente y se queda con la llave. el servicio de riesgo (pensado para LinuxONE) calcula sobre números cifrados; solo el hospital abre el resultado y ve los factores que más pesan. Es tamizaje: decide a quién hacerle primero una prueba de glucosa. (Alcance: el servicio de riesgo solo recibe cifrados; en la demo, quien administra la VM queda dentro del entorno de confianza y usamos pacientes sintéticos.)</a:t>
             </a:r>
             <a:endParaRPr lang="en-US" dirty="0"/>
           </a:p>
@@ -3555,7 +3555,7 @@
       </p:sp>
       <p:sp>
         <p:nvSpPr>
-          <p:cNvPr id="10" name="2 · LinuxONE calcula"/>
+          <p:cNvPr id="10" name="2 · El servicio calcula"/>
           <p:cNvSpPr/>
           <p:nvPr/>
         </p:nvSpPr>
@@ -3584,7 +3584,7 @@
       </p:sp>
       <p:sp>
         <p:nvSpPr>
-          <p:cNvPr id="11" name="2 · LinuxONE calcula círculo"/>
+          <p:cNvPr id="11" name="2 · El servicio calcula círculo"/>
           <p:cNvSpPr/>
           <p:nvPr/>
         </p:nvSpPr>
@@ -3604,7 +3604,7 @@
       </p:sp>
       <p:pic>
         <p:nvPicPr>
-          <p:cNvPr id="12" name="2 · LinuxONE calcula ícono" descr="preencoded.png">    </p:cNvPr>
+          <p:cNvPr id="12" name="2 · El servicio calcula ícono" descr="preencoded.png">    </p:cNvPr>
           <p:cNvPicPr>
             <a:picLocks noChangeAspect="1"/>
           </p:cNvPicPr>
@@ -3656,7 +3656,7 @@
                   <a:schemeClr val="bg1"/>
                 </a:solidFill>
               </a:rPr>
-              <a:t>2 · LinuxONE calcula</a:t>
+              <a:t>2 · El servicio calcula</a:t>
             </a:r>
             <a:endParaRPr lang="en-US" sz="1500" dirty="0"/>
           </a:p>
@@ -5843,7 +5843,7 @@
                           <a:ea typeface="Arial" pitchFamily="34" charset="-122"/>
                           <a:cs typeface="Arial" pitchFamily="34" charset="-120"/>
                         </a:rPr>
-                        <a:t>Servicio de riesgo en LinuxONE</a:t>
+                        <a:t>Servicio de riesgo (sin llaves)</a:t>
                       </a:r>
                       <a:endParaRPr lang="en-US" sz="1200" dirty="0">
                         <a:latin typeface="Arial" charset="0"/>
@@ -9884,7 +9884,7 @@
                   <a:schemeClr val="bg2"/>
                 </a:solidFill>
               </a:rPr>
-              <a:t>LinuxONE calcula w · x; el hospital descifra y aplica la sigmoide</a:t>
+              <a:t>El servicio calcula w · x sobre cifrados; el hospital descifra y aplica la sigmoide</a:t>
             </a:r>
             <a:endParaRPr lang="en-US" sz="1200" dirty="0"/>
           </a:p>

</xml_diff>